<commit_message>
changed projects a bit
</commit_message>
<xml_diff>
--- a/projects/projects.pptx
+++ b/projects/projects.pptx
@@ -5,18 +5,16 @@
     <p:sldMasterId id="2147483648" r:id="rId1"/>
   </p:sldMasterIdLst>
   <p:sldIdLst>
-    <p:sldId id="260" r:id="rId2"/>
-    <p:sldId id="276" r:id="rId3"/>
-    <p:sldId id="277" r:id="rId4"/>
-    <p:sldId id="257" r:id="rId5"/>
-    <p:sldId id="271" r:id="rId6"/>
-    <p:sldId id="272" r:id="rId7"/>
-    <p:sldId id="269" r:id="rId8"/>
-    <p:sldId id="270" r:id="rId9"/>
-    <p:sldId id="274" r:id="rId10"/>
-    <p:sldId id="275" r:id="rId11"/>
-    <p:sldId id="273" r:id="rId12"/>
-    <p:sldId id="268" r:id="rId13"/>
+    <p:sldId id="279" r:id="rId2"/>
+    <p:sldId id="281" r:id="rId3"/>
+    <p:sldId id="269" r:id="rId4"/>
+    <p:sldId id="270" r:id="rId5"/>
+    <p:sldId id="272" r:id="rId6"/>
+    <p:sldId id="257" r:id="rId7"/>
+    <p:sldId id="271" r:id="rId8"/>
+    <p:sldId id="274" r:id="rId9"/>
+    <p:sldId id="275" r:id="rId10"/>
+    <p:sldId id="273" r:id="rId11"/>
   </p:sldIdLst>
   <p:sldSz cx="12192000" cy="6858000"/>
   <p:notesSz cx="6858000" cy="9144000"/>
@@ -270,7 +268,7 @@
           <a:p>
             <a:fld id="{2EF50150-EF30-9C4C-AE3D-730A155EC207}" type="datetimeFigureOut">
               <a:rPr lang="de-DE" smtClean="0"/>
-              <a:t>28.09.25</a:t>
+              <a:t>03.10.26</a:t>
             </a:fld>
             <a:endParaRPr lang="de-DE"/>
           </a:p>
@@ -468,7 +466,7 @@
           <a:p>
             <a:fld id="{2EF50150-EF30-9C4C-AE3D-730A155EC207}" type="datetimeFigureOut">
               <a:rPr lang="de-DE" smtClean="0"/>
-              <a:t>28.09.25</a:t>
+              <a:t>03.10.26</a:t>
             </a:fld>
             <a:endParaRPr lang="de-DE"/>
           </a:p>
@@ -676,7 +674,7 @@
           <a:p>
             <a:fld id="{2EF50150-EF30-9C4C-AE3D-730A155EC207}" type="datetimeFigureOut">
               <a:rPr lang="de-DE" smtClean="0"/>
-              <a:t>28.09.25</a:t>
+              <a:t>03.10.26</a:t>
             </a:fld>
             <a:endParaRPr lang="de-DE"/>
           </a:p>
@@ -874,7 +872,7 @@
           <a:p>
             <a:fld id="{2EF50150-EF30-9C4C-AE3D-730A155EC207}" type="datetimeFigureOut">
               <a:rPr lang="de-DE" smtClean="0"/>
-              <a:t>28.09.25</a:t>
+              <a:t>03.10.26</a:t>
             </a:fld>
             <a:endParaRPr lang="de-DE"/>
           </a:p>
@@ -1149,7 +1147,7 @@
           <a:p>
             <a:fld id="{2EF50150-EF30-9C4C-AE3D-730A155EC207}" type="datetimeFigureOut">
               <a:rPr lang="de-DE" smtClean="0"/>
-              <a:t>28.09.25</a:t>
+              <a:t>03.10.26</a:t>
             </a:fld>
             <a:endParaRPr lang="de-DE"/>
           </a:p>
@@ -1414,7 +1412,7 @@
           <a:p>
             <a:fld id="{2EF50150-EF30-9C4C-AE3D-730A155EC207}" type="datetimeFigureOut">
               <a:rPr lang="de-DE" smtClean="0"/>
-              <a:t>28.09.25</a:t>
+              <a:t>03.10.26</a:t>
             </a:fld>
             <a:endParaRPr lang="de-DE"/>
           </a:p>
@@ -1826,7 +1824,7 @@
           <a:p>
             <a:fld id="{2EF50150-EF30-9C4C-AE3D-730A155EC207}" type="datetimeFigureOut">
               <a:rPr lang="de-DE" smtClean="0"/>
-              <a:t>28.09.25</a:t>
+              <a:t>03.10.26</a:t>
             </a:fld>
             <a:endParaRPr lang="de-DE"/>
           </a:p>
@@ -1967,7 +1965,7 @@
           <a:p>
             <a:fld id="{2EF50150-EF30-9C4C-AE3D-730A155EC207}" type="datetimeFigureOut">
               <a:rPr lang="de-DE" smtClean="0"/>
-              <a:t>28.09.25</a:t>
+              <a:t>03.10.26</a:t>
             </a:fld>
             <a:endParaRPr lang="de-DE"/>
           </a:p>
@@ -2080,7 +2078,7 @@
           <a:p>
             <a:fld id="{2EF50150-EF30-9C4C-AE3D-730A155EC207}" type="datetimeFigureOut">
               <a:rPr lang="de-DE" smtClean="0"/>
-              <a:t>28.09.25</a:t>
+              <a:t>03.10.26</a:t>
             </a:fld>
             <a:endParaRPr lang="de-DE"/>
           </a:p>
@@ -2391,7 +2389,7 @@
           <a:p>
             <a:fld id="{2EF50150-EF30-9C4C-AE3D-730A155EC207}" type="datetimeFigureOut">
               <a:rPr lang="de-DE" smtClean="0"/>
-              <a:t>28.09.25</a:t>
+              <a:t>03.10.26</a:t>
             </a:fld>
             <a:endParaRPr lang="de-DE"/>
           </a:p>
@@ -2679,7 +2677,7 @@
           <a:p>
             <a:fld id="{2EF50150-EF30-9C4C-AE3D-730A155EC207}" type="datetimeFigureOut">
               <a:rPr lang="de-DE" smtClean="0"/>
-              <a:t>28.09.25</a:t>
+              <a:t>03.10.26</a:t>
             </a:fld>
             <a:endParaRPr lang="de-DE"/>
           </a:p>
@@ -2920,7 +2918,7 @@
           <a:p>
             <a:fld id="{2EF50150-EF30-9C4C-AE3D-730A155EC207}" type="datetimeFigureOut">
               <a:rPr lang="de-DE" smtClean="0"/>
-              <a:t>28.09.25</a:t>
+              <a:t>03.10.26</a:t>
             </a:fld>
             <a:endParaRPr lang="de-DE"/>
           </a:p>
@@ -3325,10 +3323,620 @@
   <p:cSld>
     <p:spTree>
       <p:nvGrpSpPr>
+        <p:cNvPr id="1" name=""/>
+        <p:cNvGrpSpPr/>
+        <p:nvPr/>
+      </p:nvGrpSpPr>
+      <p:grpSpPr>
+        <a:xfrm>
+          <a:off x="0" y="0"/>
+          <a:ext cx="0" cy="0"/>
+          <a:chOff x="0" y="0"/>
+          <a:chExt cx="0" cy="0"/>
+        </a:xfrm>
+      </p:grpSpPr>
+      <p:sp>
+        <p:nvSpPr>
+          <p:cNvPr id="2" name="Titel 1">
+            <a:extLst>
+              <a:ext uri="{FF2B5EF4-FFF2-40B4-BE49-F238E27FC236}">
+                <a16:creationId xmlns:a16="http://schemas.microsoft.com/office/drawing/2014/main" id="{3A266E1B-DB55-F84A-0B5F-D9D28C710701}"/>
+              </a:ext>
+            </a:extLst>
+          </p:cNvPr>
+          <p:cNvSpPr>
+            <a:spLocks noGrp="1"/>
+          </p:cNvSpPr>
+          <p:nvPr>
+            <p:ph type="title"/>
+          </p:nvPr>
+        </p:nvSpPr>
+        <p:spPr/>
+        <p:txBody>
+          <a:bodyPr/>
+          <a:lstStyle/>
+          <a:p>
+            <a:r>
+              <a:rPr lang="de-DE" dirty="0"/>
+              <a:t>Project 1</a:t>
+            </a:r>
+          </a:p>
+        </p:txBody>
+      </p:sp>
+      <p:sp>
+        <p:nvSpPr>
+          <p:cNvPr id="3" name="Inhaltsplatzhalter 2">
+            <a:extLst>
+              <a:ext uri="{FF2B5EF4-FFF2-40B4-BE49-F238E27FC236}">
+                <a16:creationId xmlns:a16="http://schemas.microsoft.com/office/drawing/2014/main" id="{63D02B4E-C6EA-17D8-9463-FB81260E32D1}"/>
+              </a:ext>
+            </a:extLst>
+          </p:cNvPr>
+          <p:cNvSpPr>
+            <a:spLocks noGrp="1"/>
+          </p:cNvSpPr>
+          <p:nvPr>
+            <p:ph idx="1"/>
+          </p:nvPr>
+        </p:nvSpPr>
+        <p:spPr/>
+        <p:txBody>
+          <a:bodyPr>
+            <a:normAutofit fontScale="85000" lnSpcReduction="20000"/>
+          </a:bodyPr>
+          <a:lstStyle/>
+          <a:p>
+            <a:pPr marL="0" indent="0">
+              <a:buNone/>
+            </a:pPr>
+            <a:r>
+              <a:rPr lang="de-DE" sz="4000" dirty="0"/>
+              <a:t>Image Registration </a:t>
+            </a:r>
+            <a:r>
+              <a:rPr lang="de-DE" sz="4000" dirty="0" err="1"/>
+              <a:t>using</a:t>
+            </a:r>
+            <a:r>
+              <a:rPr lang="de-DE" sz="4000" dirty="0"/>
+              <a:t> the </a:t>
+            </a:r>
+            <a:r>
+              <a:rPr lang="de-DE" sz="4000" dirty="0">
+                <a:hlinkClick r:id="rId2"/>
+              </a:rPr>
+              <a:t>HPatches dataset</a:t>
+            </a:r>
+            <a:endParaRPr lang="de-DE" sz="4000" dirty="0"/>
+          </a:p>
+          <a:p>
+            <a:pPr marL="0" indent="0">
+              <a:buNone/>
+            </a:pPr>
+            <a:endParaRPr lang="de-DE" sz="2600" dirty="0"/>
+          </a:p>
+          <a:p>
+            <a:r>
+              <a:rPr lang="de-DE" sz="2600" dirty="0"/>
+              <a:t>Use </a:t>
+            </a:r>
+            <a:r>
+              <a:rPr lang="de-DE" sz="2600" dirty="0" err="1"/>
+              <a:t>only</a:t>
+            </a:r>
+            <a:r>
+              <a:rPr lang="de-DE" sz="2600" dirty="0"/>
+              <a:t> the </a:t>
+            </a:r>
+            <a:r>
+              <a:rPr lang="de-DE" sz="2600" dirty="0" err="1"/>
+              <a:t>viewpoint</a:t>
+            </a:r>
+            <a:r>
+              <a:rPr lang="de-DE" sz="2600" dirty="0"/>
+              <a:t> </a:t>
+            </a:r>
+            <a:r>
+              <a:rPr lang="de-DE" sz="2600" dirty="0" err="1"/>
+              <a:t>sequences</a:t>
+            </a:r>
+            <a:r>
+              <a:rPr lang="de-DE" sz="2600" dirty="0"/>
+              <a:t> (v_*).</a:t>
+            </a:r>
+          </a:p>
+          <a:p>
+            <a:r>
+              <a:rPr lang="de-DE" sz="2600" dirty="0" err="1"/>
+              <a:t>Each</a:t>
+            </a:r>
+            <a:r>
+              <a:rPr lang="de-DE" sz="2600" dirty="0"/>
+              <a:t> </a:t>
+            </a:r>
+            <a:r>
+              <a:rPr lang="de-DE" sz="2600" dirty="0" err="1"/>
+              <a:t>sequence</a:t>
+            </a:r>
+            <a:r>
+              <a:rPr lang="de-DE" sz="2600" dirty="0"/>
+              <a:t> </a:t>
+            </a:r>
+            <a:r>
+              <a:rPr lang="de-DE" sz="2600" dirty="0" err="1"/>
+              <a:t>folder</a:t>
+            </a:r>
+            <a:r>
+              <a:rPr lang="de-DE" sz="2600" dirty="0"/>
+              <a:t> </a:t>
+            </a:r>
+            <a:r>
+              <a:rPr lang="de-DE" sz="2600" dirty="0" err="1"/>
+              <a:t>contains</a:t>
+            </a:r>
+            <a:r>
+              <a:rPr lang="de-DE" sz="2600" dirty="0"/>
+              <a:t> a </a:t>
+            </a:r>
+            <a:r>
+              <a:rPr lang="de-DE" sz="2600" dirty="0" err="1"/>
+              <a:t>reference</a:t>
+            </a:r>
+            <a:r>
+              <a:rPr lang="de-DE" sz="2600" dirty="0"/>
+              <a:t> </a:t>
+            </a:r>
+            <a:r>
+              <a:rPr lang="de-DE" sz="2600" dirty="0" err="1"/>
+              <a:t>image</a:t>
+            </a:r>
+            <a:r>
+              <a:rPr lang="de-DE" sz="2600" dirty="0"/>
+              <a:t> (1.ppm) and 5 </a:t>
+            </a:r>
+            <a:r>
+              <a:rPr lang="de-DE" sz="2600" dirty="0" err="1"/>
+              <a:t>target</a:t>
+            </a:r>
+            <a:r>
+              <a:rPr lang="de-DE" sz="2600" dirty="0"/>
+              <a:t> </a:t>
+            </a:r>
+            <a:r>
+              <a:rPr lang="de-DE" sz="2600" dirty="0" err="1"/>
+              <a:t>images</a:t>
+            </a:r>
+            <a:r>
+              <a:rPr lang="de-DE" sz="2600" dirty="0"/>
+              <a:t> (2.ppm to 6.ppm) </a:t>
+            </a:r>
+            <a:r>
+              <a:rPr lang="de-DE" sz="2600" dirty="0" err="1"/>
+              <a:t>captured</a:t>
+            </a:r>
+            <a:r>
+              <a:rPr lang="de-DE" sz="2600" dirty="0"/>
+              <a:t> </a:t>
+            </a:r>
+            <a:r>
+              <a:rPr lang="de-DE" sz="2600" dirty="0" err="1"/>
+              <a:t>from</a:t>
+            </a:r>
+            <a:r>
+              <a:rPr lang="de-DE" sz="2600" dirty="0"/>
+              <a:t> </a:t>
+            </a:r>
+            <a:r>
+              <a:rPr lang="de-DE" sz="2600" dirty="0" err="1"/>
+              <a:t>increasingly</a:t>
+            </a:r>
+            <a:r>
+              <a:rPr lang="de-DE" sz="2600" dirty="0"/>
+              <a:t> extreme </a:t>
+            </a:r>
+            <a:r>
+              <a:rPr lang="de-DE" sz="2600" dirty="0" err="1"/>
+              <a:t>viewing</a:t>
+            </a:r>
+            <a:r>
+              <a:rPr lang="de-DE" sz="2600" dirty="0"/>
+              <a:t> </a:t>
+            </a:r>
+            <a:r>
+              <a:rPr lang="de-DE" sz="2600" dirty="0" err="1"/>
+              <a:t>angles</a:t>
+            </a:r>
+            <a:r>
+              <a:rPr lang="de-DE" sz="2600" dirty="0"/>
+              <a:t>.</a:t>
+            </a:r>
+          </a:p>
+          <a:p>
+            <a:r>
+              <a:rPr lang="de-DE" sz="2600" dirty="0"/>
+              <a:t>Tasks per </a:t>
+            </a:r>
+            <a:r>
+              <a:rPr lang="de-DE" sz="2600" dirty="0" err="1"/>
+              <a:t>Sequence</a:t>
+            </a:r>
+            <a:r>
+              <a:rPr lang="de-DE" sz="2600" dirty="0"/>
+              <a:t>:</a:t>
+            </a:r>
+          </a:p>
+          <a:p>
+            <a:pPr lvl="1"/>
+            <a:r>
+              <a:rPr lang="de-DE" sz="2600" dirty="0" err="1"/>
+              <a:t>Estimate</a:t>
+            </a:r>
+            <a:r>
+              <a:rPr lang="de-DE" sz="2600" dirty="0"/>
+              <a:t> the </a:t>
+            </a:r>
+            <a:r>
+              <a:rPr lang="de-DE" sz="2600" dirty="0" err="1"/>
+              <a:t>homography</a:t>
+            </a:r>
+            <a:r>
+              <a:rPr lang="de-DE" sz="2600" dirty="0"/>
+              <a:t> </a:t>
+            </a:r>
+            <a:r>
+              <a:rPr lang="de-DE" sz="2600" dirty="0" err="1"/>
+              <a:t>matrix</a:t>
+            </a:r>
+            <a:r>
+              <a:rPr lang="de-DE" sz="2600" dirty="0"/>
+              <a:t> </a:t>
+            </a:r>
+            <a:r>
+              <a:rPr lang="de-DE" sz="2600" dirty="0" err="1"/>
+              <a:t>between</a:t>
+            </a:r>
+            <a:r>
+              <a:rPr lang="de-DE" sz="2600" dirty="0"/>
+              <a:t> the </a:t>
+            </a:r>
+            <a:r>
+              <a:rPr lang="de-DE" sz="2600" dirty="0" err="1"/>
+              <a:t>reference</a:t>
+            </a:r>
+            <a:r>
+              <a:rPr lang="de-DE" sz="2600" dirty="0"/>
+              <a:t> </a:t>
+            </a:r>
+            <a:r>
+              <a:rPr lang="de-DE" sz="2600" dirty="0" err="1"/>
+              <a:t>image</a:t>
+            </a:r>
+            <a:r>
+              <a:rPr lang="de-DE" sz="2600" dirty="0"/>
+              <a:t> and </a:t>
+            </a:r>
+            <a:r>
+              <a:rPr lang="de-DE" sz="2600" dirty="0" err="1"/>
+              <a:t>each</a:t>
+            </a:r>
+            <a:r>
+              <a:rPr lang="de-DE" sz="2600" dirty="0"/>
+              <a:t> of the 5 </a:t>
+            </a:r>
+            <a:r>
+              <a:rPr lang="de-DE" sz="2600" dirty="0" err="1"/>
+              <a:t>target</a:t>
+            </a:r>
+            <a:r>
+              <a:rPr lang="de-DE" sz="2600" dirty="0"/>
+              <a:t> </a:t>
+            </a:r>
+            <a:r>
+              <a:rPr lang="de-DE" sz="2600" dirty="0" err="1"/>
+              <a:t>images</a:t>
+            </a:r>
+            <a:r>
+              <a:rPr lang="de-DE" sz="2600" dirty="0"/>
+              <a:t>.</a:t>
+            </a:r>
+          </a:p>
+          <a:p>
+            <a:pPr lvl="1"/>
+            <a:r>
+              <a:rPr lang="de-DE" sz="2600" dirty="0" err="1"/>
+              <a:t>Compare</a:t>
+            </a:r>
+            <a:r>
+              <a:rPr lang="de-DE" sz="2600" dirty="0"/>
+              <a:t> </a:t>
+            </a:r>
+            <a:r>
+              <a:rPr lang="de-DE" sz="2600" dirty="0" err="1"/>
+              <a:t>your</a:t>
+            </a:r>
+            <a:r>
+              <a:rPr lang="de-DE" sz="2600" dirty="0"/>
+              <a:t> </a:t>
+            </a:r>
+            <a:r>
+              <a:rPr lang="de-DE" sz="2600" dirty="0" err="1"/>
+              <a:t>estimated</a:t>
+            </a:r>
+            <a:r>
+              <a:rPr lang="de-DE" sz="2600" dirty="0"/>
+              <a:t> </a:t>
+            </a:r>
+            <a:r>
+              <a:rPr lang="de-DE" sz="2600" dirty="0" err="1"/>
+              <a:t>matrix</a:t>
+            </a:r>
+            <a:r>
+              <a:rPr lang="de-DE" sz="2600" dirty="0"/>
+              <a:t> </a:t>
+            </a:r>
+            <a:r>
+              <a:rPr lang="de-DE" sz="2600" dirty="0" err="1"/>
+              <a:t>against</a:t>
+            </a:r>
+            <a:r>
+              <a:rPr lang="de-DE" sz="2600" dirty="0"/>
+              <a:t> the </a:t>
+            </a:r>
+            <a:r>
+              <a:rPr lang="de-DE" sz="2600" dirty="0" err="1"/>
+              <a:t>provided</a:t>
+            </a:r>
+            <a:r>
+              <a:rPr lang="de-DE" sz="2600" dirty="0"/>
+              <a:t> </a:t>
+            </a:r>
+            <a:r>
+              <a:rPr lang="de-DE" sz="2600" dirty="0" err="1"/>
+              <a:t>ground</a:t>
+            </a:r>
+            <a:r>
+              <a:rPr lang="de-DE" sz="2600" dirty="0"/>
+              <a:t> </a:t>
+            </a:r>
+            <a:r>
+              <a:rPr lang="de-DE" sz="2600" dirty="0" err="1"/>
+              <a:t>truth</a:t>
+            </a:r>
+            <a:r>
+              <a:rPr lang="de-DE" sz="2600" dirty="0"/>
+              <a:t> (H) by </a:t>
+            </a:r>
+            <a:r>
+              <a:rPr lang="de-DE" sz="2600" dirty="0" err="1"/>
+              <a:t>calculating</a:t>
+            </a:r>
+            <a:r>
+              <a:rPr lang="de-DE" sz="2600" dirty="0"/>
+              <a:t> the Corner Error. This </a:t>
+            </a:r>
+            <a:r>
+              <a:rPr lang="de-DE" sz="2600" dirty="0" err="1"/>
+              <a:t>is</a:t>
+            </a:r>
+            <a:r>
+              <a:rPr lang="de-DE" sz="2600" dirty="0"/>
+              <a:t> </a:t>
+            </a:r>
+            <a:r>
+              <a:rPr lang="de-DE" sz="2600" dirty="0" err="1"/>
+              <a:t>defined</a:t>
+            </a:r>
+            <a:r>
+              <a:rPr lang="de-DE" sz="2600" dirty="0"/>
+              <a:t> as the RMSE in </a:t>
+            </a:r>
+            <a:r>
+              <a:rPr lang="de-DE" sz="2600" dirty="0" err="1"/>
+              <a:t>pixel</a:t>
+            </a:r>
+            <a:r>
+              <a:rPr lang="de-DE" sz="2600" dirty="0"/>
+              <a:t> </a:t>
+            </a:r>
+            <a:r>
+              <a:rPr lang="de-DE" sz="2600" dirty="0" err="1"/>
+              <a:t>distance</a:t>
+            </a:r>
+            <a:r>
+              <a:rPr lang="de-DE" sz="2600" dirty="0"/>
+              <a:t> </a:t>
+            </a:r>
+            <a:r>
+              <a:rPr lang="de-DE" sz="2600" dirty="0" err="1"/>
+              <a:t>between</a:t>
+            </a:r>
+            <a:r>
+              <a:rPr lang="de-DE" sz="2600" dirty="0"/>
+              <a:t> the </a:t>
+            </a:r>
+            <a:r>
+              <a:rPr lang="de-DE" sz="2600" dirty="0" err="1"/>
+              <a:t>corners</a:t>
+            </a:r>
+            <a:r>
+              <a:rPr lang="de-DE" sz="2600" dirty="0"/>
+              <a:t> </a:t>
+            </a:r>
+            <a:r>
+              <a:rPr lang="de-DE" sz="2600" dirty="0" err="1"/>
+              <a:t>transformed</a:t>
+            </a:r>
+            <a:r>
+              <a:rPr lang="de-DE" sz="2600" dirty="0"/>
+              <a:t> by </a:t>
+            </a:r>
+            <a:r>
+              <a:rPr lang="de-DE" sz="2600" dirty="0" err="1"/>
+              <a:t>your</a:t>
+            </a:r>
+            <a:r>
+              <a:rPr lang="de-DE" sz="2600" dirty="0"/>
+              <a:t> </a:t>
+            </a:r>
+            <a:r>
+              <a:rPr lang="de-DE" sz="2600" dirty="0" err="1"/>
+              <a:t>estimated</a:t>
+            </a:r>
+            <a:r>
+              <a:rPr lang="de-DE" sz="2600" dirty="0"/>
+              <a:t> </a:t>
+            </a:r>
+            <a:r>
+              <a:rPr lang="de-DE" sz="2600" dirty="0" err="1"/>
+              <a:t>matrix</a:t>
+            </a:r>
+            <a:r>
+              <a:rPr lang="de-DE" sz="2600" dirty="0"/>
+              <a:t> and the </a:t>
+            </a:r>
+            <a:r>
+              <a:rPr lang="de-DE" sz="2600" dirty="0" err="1"/>
+              <a:t>ground-truth-transformed</a:t>
+            </a:r>
+            <a:r>
+              <a:rPr lang="de-DE" sz="2600" dirty="0"/>
+              <a:t> </a:t>
+            </a:r>
+            <a:r>
+              <a:rPr lang="de-DE" sz="2600" dirty="0" err="1"/>
+              <a:t>corners</a:t>
+            </a:r>
+            <a:r>
+              <a:rPr lang="de-DE" sz="2600" dirty="0"/>
+              <a:t>.</a:t>
+            </a:r>
+          </a:p>
+          <a:p>
+            <a:r>
+              <a:rPr lang="de-DE" sz="2600" dirty="0"/>
+              <a:t>Evaluation: </a:t>
+            </a:r>
+            <a:r>
+              <a:rPr lang="de-DE" sz="2600" dirty="0" err="1"/>
+              <a:t>Calculate</a:t>
+            </a:r>
+            <a:r>
+              <a:rPr lang="de-DE" sz="2600" dirty="0"/>
+              <a:t> and </a:t>
+            </a:r>
+            <a:r>
+              <a:rPr lang="de-DE" sz="2600" dirty="0" err="1"/>
+              <a:t>plot</a:t>
+            </a:r>
+            <a:r>
+              <a:rPr lang="de-DE" sz="2600" dirty="0"/>
+              <a:t> the </a:t>
+            </a:r>
+            <a:r>
+              <a:rPr lang="de-DE" sz="2600" dirty="0" err="1"/>
+              <a:t>average</a:t>
+            </a:r>
+            <a:r>
+              <a:rPr lang="de-DE" sz="2600" dirty="0"/>
+              <a:t> </a:t>
+            </a:r>
+            <a:r>
+              <a:rPr lang="de-DE" sz="2600" dirty="0" err="1"/>
+              <a:t>corner</a:t>
+            </a:r>
+            <a:r>
+              <a:rPr lang="de-DE" sz="2600" dirty="0"/>
+              <a:t> </a:t>
+            </a:r>
+            <a:r>
+              <a:rPr lang="de-DE" sz="2600" dirty="0" err="1"/>
+              <a:t>error</a:t>
+            </a:r>
+            <a:r>
+              <a:rPr lang="de-DE" sz="2600" dirty="0"/>
+              <a:t> </a:t>
+            </a:r>
+            <a:r>
+              <a:rPr lang="de-DE" sz="2600" dirty="0" err="1"/>
+              <a:t>across</a:t>
+            </a:r>
+            <a:r>
+              <a:rPr lang="de-DE" sz="2600" dirty="0"/>
+              <a:t> all </a:t>
+            </a:r>
+            <a:r>
+              <a:rPr lang="de-DE" sz="2600" dirty="0" err="1"/>
+              <a:t>processed</a:t>
+            </a:r>
+            <a:r>
+              <a:rPr lang="de-DE" sz="2600" dirty="0"/>
+              <a:t> </a:t>
+            </a:r>
+            <a:r>
+              <a:rPr lang="de-DE" sz="2600" dirty="0" err="1"/>
+              <a:t>sequences</a:t>
+            </a:r>
+            <a:r>
+              <a:rPr lang="de-DE" sz="2600" dirty="0"/>
+              <a:t> for </a:t>
+            </a:r>
+            <a:r>
+              <a:rPr lang="de-DE" sz="2600" dirty="0" err="1"/>
+              <a:t>each</a:t>
+            </a:r>
+            <a:r>
+              <a:rPr lang="de-DE" sz="2600" dirty="0"/>
+              <a:t> </a:t>
+            </a:r>
+            <a:r>
+              <a:rPr lang="de-DE" sz="2600" dirty="0" err="1"/>
+              <a:t>target</a:t>
+            </a:r>
+            <a:r>
+              <a:rPr lang="de-DE" sz="2600" dirty="0"/>
+              <a:t> </a:t>
+            </a:r>
+            <a:r>
+              <a:rPr lang="de-DE" sz="2600" dirty="0" err="1"/>
+              <a:t>image</a:t>
+            </a:r>
+            <a:r>
+              <a:rPr lang="de-DE" sz="2600" dirty="0"/>
+              <a:t> </a:t>
+            </a:r>
+            <a:r>
+              <a:rPr lang="de-DE" sz="2600" dirty="0" err="1"/>
+              <a:t>stage</a:t>
+            </a:r>
+            <a:r>
+              <a:rPr lang="de-DE" sz="2600" dirty="0"/>
+              <a:t> (2–6).</a:t>
+            </a:r>
+          </a:p>
+        </p:txBody>
+      </p:sp>
+    </p:spTree>
+    <p:extLst>
+      <p:ext uri="{BB962C8B-B14F-4D97-AF65-F5344CB8AC3E}">
+        <p14:creationId xmlns:p14="http://schemas.microsoft.com/office/powerpoint/2010/main" val="4167682904"/>
+      </p:ext>
+    </p:extLst>
+  </p:cSld>
+  <p:clrMapOvr>
+    <a:masterClrMapping/>
+  </p:clrMapOvr>
+</p:sld>
+</file>
+
+<file path=ppt/slides/slide10.xml><?xml version="1.0" encoding="utf-8"?>
+<p:sld xmlns:a="http://schemas.openxmlformats.org/drawingml/2006/main" xmlns:r="http://schemas.openxmlformats.org/officeDocument/2006/relationships" xmlns:p="http://schemas.openxmlformats.org/presentationml/2006/main">
+  <p:cSld>
+    <p:spTree>
+      <p:nvGrpSpPr>
         <p:cNvPr id="1" name="">
           <a:extLst>
             <a:ext uri="{FF2B5EF4-FFF2-40B4-BE49-F238E27FC236}">
-              <a16:creationId xmlns:a16="http://schemas.microsoft.com/office/drawing/2014/main" id="{63914AD3-EC20-B5CD-5951-312284578BE3}"/>
+              <a16:creationId xmlns:a16="http://schemas.microsoft.com/office/drawing/2014/main" id="{37AA4DEC-E6EA-8DF2-B8BC-466413A3C89A}"/>
             </a:ext>
           </a:extLst>
         </p:cNvPr>
@@ -3348,7 +3956,7 @@
           <p:cNvPr id="2" name="Titel 1">
             <a:extLst>
               <a:ext uri="{FF2B5EF4-FFF2-40B4-BE49-F238E27FC236}">
-                <a16:creationId xmlns:a16="http://schemas.microsoft.com/office/drawing/2014/main" id="{7ED6ACBF-8927-875D-94AE-EDC67309F8D2}"/>
+                <a16:creationId xmlns:a16="http://schemas.microsoft.com/office/drawing/2014/main" id="{6B0CA98E-420F-4198-5AAD-D0C7B0099F39}"/>
               </a:ext>
             </a:extLst>
           </p:cNvPr>
@@ -3366,7 +3974,7 @@
           <a:p>
             <a:r>
               <a:rPr lang="de-DE" dirty="0"/>
-              <a:t>Project 1: Group 1</a:t>
+              <a:t>Project 10</a:t>
             </a:r>
           </a:p>
         </p:txBody>
@@ -3376,7 +3984,7 @@
           <p:cNvPr id="3" name="Inhaltsplatzhalter 2">
             <a:extLst>
               <a:ext uri="{FF2B5EF4-FFF2-40B4-BE49-F238E27FC236}">
-                <a16:creationId xmlns:a16="http://schemas.microsoft.com/office/drawing/2014/main" id="{04568C2A-AEFC-5D0D-7227-BE045F3EAAC7}"/>
+                <a16:creationId xmlns:a16="http://schemas.microsoft.com/office/drawing/2014/main" id="{926DF603-70FC-D4F1-72F2-C28983AE2ACA}"/>
               </a:ext>
             </a:extLst>
           </p:cNvPr>
@@ -3389,173 +3997,42 @@
         </p:nvSpPr>
         <p:spPr/>
         <p:txBody>
-          <a:bodyPr/>
-          <a:lstStyle/>
-          <a:p>
-            <a:pPr marL="0" indent="0">
+          <a:bodyPr>
+            <a:normAutofit/>
+          </a:bodyPr>
+          <a:lstStyle/>
+          <a:p>
+            <a:pPr marL="0" indent="0" algn="ctr">
               <a:buNone/>
             </a:pPr>
-            <a:r>
-              <a:rPr lang="de-DE" sz="4200" dirty="0"/>
-              <a:t>Feature-</a:t>
-            </a:r>
-            <a:r>
-              <a:rPr lang="de-DE" sz="4200" dirty="0" err="1"/>
-              <a:t>based</a:t>
-            </a:r>
-            <a:r>
-              <a:rPr lang="de-DE" sz="4200" dirty="0"/>
-              <a:t> </a:t>
-            </a:r>
-            <a:r>
-              <a:rPr lang="de-DE" sz="4200" dirty="0" err="1"/>
-              <a:t>Object</a:t>
-            </a:r>
-            <a:r>
-              <a:rPr lang="de-DE" sz="4200" dirty="0"/>
-              <a:t> Recognition</a:t>
-            </a:r>
-          </a:p>
-          <a:p>
-            <a:pPr marL="0" indent="0">
+            <a:endParaRPr lang="de-DE" sz="5000" dirty="0"/>
+          </a:p>
+          <a:p>
+            <a:pPr marL="0" indent="0" algn="ctr">
               <a:buNone/>
             </a:pPr>
-            <a:endParaRPr lang="de-DE" dirty="0"/>
-          </a:p>
-          <a:p>
-            <a:pPr marL="0" indent="0">
+            <a:endParaRPr lang="de-DE" sz="5000" dirty="0">
+              <a:hlinkClick r:id="rId2"/>
+            </a:endParaRPr>
+          </a:p>
+          <a:p>
+            <a:pPr marL="0" indent="0" algn="ctr">
               <a:buNone/>
             </a:pPr>
             <a:r>
-              <a:rPr lang="de-DE" dirty="0"/>
-              <a:t>Find </a:t>
-            </a:r>
-            <a:r>
-              <a:rPr lang="de-DE" dirty="0" err="1"/>
-              <a:t>some</a:t>
-            </a:r>
-            <a:r>
-              <a:rPr lang="de-DE" dirty="0"/>
-              <a:t> </a:t>
-            </a:r>
-            <a:r>
-              <a:rPr lang="de-DE" dirty="0" err="1"/>
-              <a:t>specific</a:t>
-            </a:r>
-            <a:r>
-              <a:rPr lang="de-DE" dirty="0"/>
-              <a:t> </a:t>
-            </a:r>
-            <a:r>
-              <a:rPr lang="de-DE" dirty="0" err="1"/>
-              <a:t>objects</a:t>
-            </a:r>
-            <a:r>
-              <a:rPr lang="de-DE" dirty="0"/>
-              <a:t> </a:t>
-            </a:r>
-            <a:r>
-              <a:rPr lang="de-DE" dirty="0" err="1"/>
-              <a:t>within</a:t>
-            </a:r>
-            <a:r>
-              <a:rPr lang="de-DE" dirty="0"/>
-              <a:t> larger </a:t>
-            </a:r>
-            <a:r>
-              <a:rPr lang="de-DE" dirty="0" err="1"/>
-              <a:t>images</a:t>
-            </a:r>
-            <a:r>
-              <a:rPr lang="de-DE" dirty="0"/>
-              <a:t>.</a:t>
-            </a:r>
-          </a:p>
-          <a:p>
-            <a:pPr marL="0" indent="0">
-              <a:buNone/>
-            </a:pPr>
-            <a:endParaRPr lang="de-DE" dirty="0"/>
-          </a:p>
-          <a:p>
-            <a:pPr marL="0" indent="0">
-              <a:buNone/>
-            </a:pPr>
-            <a:r>
-              <a:rPr lang="de-DE" dirty="0"/>
-              <a:t>(</a:t>
-            </a:r>
-            <a:r>
-              <a:rPr lang="de-DE" dirty="0" err="1"/>
-              <a:t>You</a:t>
-            </a:r>
-            <a:r>
-              <a:rPr lang="de-DE" dirty="0"/>
-              <a:t> </a:t>
-            </a:r>
-            <a:r>
-              <a:rPr lang="de-DE" dirty="0" err="1"/>
-              <a:t>can</a:t>
-            </a:r>
-            <a:r>
-              <a:rPr lang="de-DE" dirty="0"/>
-              <a:t> </a:t>
-            </a:r>
-            <a:r>
-              <a:rPr lang="de-DE" dirty="0" err="1"/>
-              <a:t>use</a:t>
-            </a:r>
-            <a:r>
-              <a:rPr lang="de-DE" dirty="0"/>
-              <a:t> </a:t>
-            </a:r>
-            <a:r>
-              <a:rPr lang="de-DE" dirty="0" err="1"/>
-              <a:t>any</a:t>
-            </a:r>
-            <a:r>
-              <a:rPr lang="de-DE" dirty="0"/>
-              <a:t> </a:t>
-            </a:r>
-            <a:r>
-              <a:rPr lang="de-DE" dirty="0" err="1"/>
-              <a:t>images</a:t>
-            </a:r>
-            <a:r>
-              <a:rPr lang="de-DE" dirty="0"/>
-              <a:t> </a:t>
-            </a:r>
-            <a:r>
-              <a:rPr lang="de-DE" dirty="0" err="1"/>
-              <a:t>you</a:t>
-            </a:r>
-            <a:r>
-              <a:rPr lang="de-DE" dirty="0"/>
-              <a:t> like </a:t>
-            </a:r>
-            <a:r>
-              <a:rPr lang="de-DE" dirty="0" err="1"/>
-              <a:t>for</a:t>
-            </a:r>
-            <a:r>
-              <a:rPr lang="de-DE" dirty="0"/>
-              <a:t> </a:t>
-            </a:r>
-            <a:r>
-              <a:rPr lang="de-DE" dirty="0" err="1"/>
-              <a:t>this</a:t>
-            </a:r>
-            <a:r>
-              <a:rPr lang="de-DE" dirty="0"/>
-              <a:t>.)</a:t>
-            </a:r>
+              <a:rPr lang="de-DE" sz="5000" dirty="0">
+                <a:hlinkClick r:id="rId2"/>
+              </a:rPr>
+              <a:t>Fruit Detection</a:t>
+            </a:r>
+            <a:endParaRPr lang="de-DE" sz="5000" dirty="0"/>
           </a:p>
         </p:txBody>
       </p:sp>
     </p:spTree>
     <p:extLst>
       <p:ext uri="{BB962C8B-B14F-4D97-AF65-F5344CB8AC3E}">
-        <p14:creationId xmlns:p14="http://schemas.microsoft.com/office/powerpoint/2010/main" val="109856387"/>
+        <p14:creationId xmlns:p14="http://schemas.microsoft.com/office/powerpoint/2010/main" val="607152652"/>
       </p:ext>
     </p:extLst>
   </p:cSld>
@@ -3565,7 +4042,1354 @@
 </p:sld>
 </file>
 
-<file path=ppt/slides/slide10.xml><?xml version="1.0" encoding="utf-8"?>
+<file path=ppt/slides/slide2.xml><?xml version="1.0" encoding="utf-8"?>
+<p:sld xmlns:a="http://schemas.openxmlformats.org/drawingml/2006/main" xmlns:r="http://schemas.openxmlformats.org/officeDocument/2006/relationships" xmlns:p="http://schemas.openxmlformats.org/presentationml/2006/main">
+  <p:cSld>
+    <p:spTree>
+      <p:nvGrpSpPr>
+        <p:cNvPr id="1" name="">
+          <a:extLst>
+            <a:ext uri="{FF2B5EF4-FFF2-40B4-BE49-F238E27FC236}">
+              <a16:creationId xmlns:a16="http://schemas.microsoft.com/office/drawing/2014/main" id="{F55B7EDC-DE07-3ED3-1E7C-E50C131DDF1C}"/>
+            </a:ext>
+          </a:extLst>
+        </p:cNvPr>
+        <p:cNvGrpSpPr/>
+        <p:nvPr/>
+      </p:nvGrpSpPr>
+      <p:grpSpPr>
+        <a:xfrm>
+          <a:off x="0" y="0"/>
+          <a:ext cx="0" cy="0"/>
+          <a:chOff x="0" y="0"/>
+          <a:chExt cx="0" cy="0"/>
+        </a:xfrm>
+      </p:grpSpPr>
+      <p:sp>
+        <p:nvSpPr>
+          <p:cNvPr id="2" name="Titel 1">
+            <a:extLst>
+              <a:ext uri="{FF2B5EF4-FFF2-40B4-BE49-F238E27FC236}">
+                <a16:creationId xmlns:a16="http://schemas.microsoft.com/office/drawing/2014/main" id="{7F1C4F5E-D928-F10A-950E-1A5B2D07EDA6}"/>
+              </a:ext>
+            </a:extLst>
+          </p:cNvPr>
+          <p:cNvSpPr>
+            <a:spLocks noGrp="1"/>
+          </p:cNvSpPr>
+          <p:nvPr>
+            <p:ph type="title"/>
+          </p:nvPr>
+        </p:nvSpPr>
+        <p:spPr/>
+        <p:txBody>
+          <a:bodyPr/>
+          <a:lstStyle/>
+          <a:p>
+            <a:r>
+              <a:rPr lang="de-DE" dirty="0"/>
+              <a:t>Project 2</a:t>
+            </a:r>
+          </a:p>
+        </p:txBody>
+      </p:sp>
+      <p:sp>
+        <p:nvSpPr>
+          <p:cNvPr id="3" name="Inhaltsplatzhalter 2">
+            <a:extLst>
+              <a:ext uri="{FF2B5EF4-FFF2-40B4-BE49-F238E27FC236}">
+                <a16:creationId xmlns:a16="http://schemas.microsoft.com/office/drawing/2014/main" id="{FF8B6693-01E6-B446-7512-17262A717ECB}"/>
+              </a:ext>
+            </a:extLst>
+          </p:cNvPr>
+          <p:cNvSpPr>
+            <a:spLocks noGrp="1"/>
+          </p:cNvSpPr>
+          <p:nvPr>
+            <p:ph idx="1"/>
+          </p:nvPr>
+        </p:nvSpPr>
+        <p:spPr/>
+        <p:txBody>
+          <a:bodyPr>
+            <a:normAutofit fontScale="77500" lnSpcReduction="20000"/>
+          </a:bodyPr>
+          <a:lstStyle/>
+          <a:p>
+            <a:pPr marL="0" indent="0">
+              <a:buNone/>
+            </a:pPr>
+            <a:r>
+              <a:rPr lang="de-DE" sz="3600" dirty="0"/>
+              <a:t>Image Retrieval </a:t>
+            </a:r>
+            <a:r>
+              <a:rPr lang="de-DE" sz="3600" dirty="0" err="1"/>
+              <a:t>using</a:t>
+            </a:r>
+            <a:r>
+              <a:rPr lang="de-DE" sz="3600" dirty="0"/>
+              <a:t> the </a:t>
+            </a:r>
+            <a:r>
+              <a:rPr lang="de-DE" sz="3600" dirty="0">
+                <a:hlinkClick r:id="rId2"/>
+              </a:rPr>
+              <a:t>Google Landmarks Dataset v2 Micro</a:t>
+            </a:r>
+            <a:endParaRPr lang="de-DE" sz="3600" dirty="0"/>
+          </a:p>
+          <a:p>
+            <a:pPr marL="0" indent="0">
+              <a:buNone/>
+            </a:pPr>
+            <a:endParaRPr lang="de-DE" dirty="0"/>
+          </a:p>
+          <a:p>
+            <a:r>
+              <a:rPr lang="de-DE" dirty="0" err="1"/>
+              <a:t>There</a:t>
+            </a:r>
+            <a:r>
+              <a:rPr lang="de-DE" dirty="0"/>
+              <a:t> </a:t>
+            </a:r>
+            <a:r>
+              <a:rPr lang="de-DE" dirty="0" err="1"/>
+              <a:t>are</a:t>
+            </a:r>
+            <a:r>
+              <a:rPr lang="de-DE" dirty="0"/>
+              <a:t> </a:t>
+            </a:r>
+            <a:r>
+              <a:rPr lang="de-DE" dirty="0" err="1"/>
+              <a:t>images</a:t>
+            </a:r>
+            <a:r>
+              <a:rPr lang="de-DE" dirty="0"/>
+              <a:t> </a:t>
+            </a:r>
+            <a:r>
+              <a:rPr lang="de-DE" dirty="0" err="1"/>
+              <a:t>from</a:t>
+            </a:r>
+            <a:r>
+              <a:rPr lang="de-DE" dirty="0"/>
+              <a:t> 3103 </a:t>
+            </a:r>
+            <a:r>
+              <a:rPr lang="de-DE" dirty="0" err="1"/>
+              <a:t>distinct</a:t>
+            </a:r>
+            <a:r>
+              <a:rPr lang="de-DE" dirty="0"/>
+              <a:t> </a:t>
+            </a:r>
+            <a:r>
+              <a:rPr lang="de-DE" dirty="0" err="1"/>
+              <a:t>landmarks</a:t>
+            </a:r>
+            <a:r>
+              <a:rPr lang="de-DE" dirty="0"/>
+              <a:t>. In gldv2_micro.csv, </a:t>
+            </a:r>
+            <a:r>
+              <a:rPr lang="de-DE" dirty="0" err="1"/>
+              <a:t>you</a:t>
+            </a:r>
+            <a:r>
+              <a:rPr lang="de-DE" dirty="0"/>
+              <a:t> </a:t>
+            </a:r>
+            <a:r>
+              <a:rPr lang="de-DE" dirty="0" err="1"/>
+              <a:t>can</a:t>
+            </a:r>
+            <a:r>
+              <a:rPr lang="de-DE" dirty="0"/>
+              <a:t> find the global </a:t>
+            </a:r>
+            <a:r>
+              <a:rPr lang="de-DE" dirty="0" err="1"/>
+              <a:t>landmark</a:t>
+            </a:r>
+            <a:r>
+              <a:rPr lang="de-DE" dirty="0"/>
+              <a:t> ID for </a:t>
+            </a:r>
+            <a:r>
+              <a:rPr lang="de-DE" dirty="0" err="1"/>
+              <a:t>each</a:t>
+            </a:r>
+            <a:r>
+              <a:rPr lang="de-DE" dirty="0"/>
+              <a:t> </a:t>
+            </a:r>
+            <a:r>
+              <a:rPr lang="de-DE" dirty="0" err="1"/>
+              <a:t>image</a:t>
+            </a:r>
+            <a:r>
+              <a:rPr lang="de-DE" dirty="0"/>
+              <a:t>.</a:t>
+            </a:r>
+          </a:p>
+          <a:p>
+            <a:r>
+              <a:rPr lang="de-DE" dirty="0"/>
+              <a:t>The </a:t>
+            </a:r>
+            <a:r>
+              <a:rPr lang="de-DE" dirty="0" err="1"/>
+              <a:t>query</a:t>
+            </a:r>
+            <a:r>
+              <a:rPr lang="de-DE" dirty="0"/>
+              <a:t> </a:t>
+            </a:r>
+            <a:r>
+              <a:rPr lang="de-DE" dirty="0" err="1"/>
+              <a:t>images</a:t>
+            </a:r>
+            <a:r>
+              <a:rPr lang="de-DE" dirty="0"/>
+              <a:t> </a:t>
+            </a:r>
+            <a:r>
+              <a:rPr lang="de-DE" dirty="0" err="1"/>
+              <a:t>can</a:t>
+            </a:r>
+            <a:r>
+              <a:rPr lang="de-DE" dirty="0"/>
+              <a:t> </a:t>
+            </a:r>
+            <a:r>
+              <a:rPr lang="de-DE" dirty="0" err="1"/>
+              <a:t>be</a:t>
+            </a:r>
+            <a:r>
+              <a:rPr lang="de-DE" dirty="0"/>
+              <a:t> </a:t>
+            </a:r>
+            <a:r>
+              <a:rPr lang="de-DE" dirty="0" err="1"/>
+              <a:t>found</a:t>
+            </a:r>
+            <a:r>
+              <a:rPr lang="de-DE" dirty="0"/>
+              <a:t> in </a:t>
+            </a:r>
+            <a:r>
+              <a:rPr lang="de-DE" dirty="0" err="1"/>
+              <a:t>val.csv</a:t>
+            </a:r>
+            <a:r>
+              <a:rPr lang="de-DE" dirty="0"/>
+              <a:t> (and </a:t>
+            </a:r>
+            <a:r>
+              <a:rPr lang="de-DE" dirty="0" err="1"/>
+              <a:t>train.csv</a:t>
+            </a:r>
+            <a:r>
+              <a:rPr lang="de-DE" dirty="0"/>
+              <a:t>). Note </a:t>
+            </a:r>
+            <a:r>
+              <a:rPr lang="de-DE" dirty="0" err="1"/>
+              <a:t>that</a:t>
+            </a:r>
+            <a:r>
+              <a:rPr lang="de-DE" dirty="0"/>
+              <a:t> the </a:t>
+            </a:r>
+            <a:r>
+              <a:rPr lang="de-DE" dirty="0" err="1"/>
+              <a:t>landmark_id</a:t>
+            </a:r>
+            <a:r>
+              <a:rPr lang="de-DE" dirty="0"/>
+              <a:t> </a:t>
+            </a:r>
+            <a:r>
+              <a:rPr lang="de-DE" dirty="0" err="1"/>
+              <a:t>values</a:t>
+            </a:r>
+            <a:r>
+              <a:rPr lang="de-DE" dirty="0"/>
+              <a:t> in </a:t>
+            </a:r>
+            <a:r>
+              <a:rPr lang="de-DE" dirty="0" err="1"/>
+              <a:t>val.csv</a:t>
+            </a:r>
+            <a:r>
+              <a:rPr lang="de-DE" dirty="0"/>
+              <a:t> </a:t>
+            </a:r>
+            <a:r>
+              <a:rPr lang="de-DE" dirty="0" err="1"/>
+              <a:t>are</a:t>
+            </a:r>
+            <a:r>
+              <a:rPr lang="de-DE" dirty="0"/>
+              <a:t> different </a:t>
+            </a:r>
+            <a:r>
+              <a:rPr lang="de-DE" dirty="0" err="1"/>
+              <a:t>from</a:t>
+            </a:r>
+            <a:r>
+              <a:rPr lang="de-DE" dirty="0"/>
+              <a:t> the </a:t>
+            </a:r>
+            <a:r>
+              <a:rPr lang="de-DE" dirty="0" err="1"/>
+              <a:t>ones</a:t>
+            </a:r>
+            <a:r>
+              <a:rPr lang="de-DE" dirty="0"/>
+              <a:t> in gldv2_micro.csv for the same </a:t>
+            </a:r>
+            <a:r>
+              <a:rPr lang="de-DE" dirty="0" err="1"/>
+              <a:t>images</a:t>
+            </a:r>
+            <a:r>
+              <a:rPr lang="de-DE" dirty="0"/>
+              <a:t>. </a:t>
+            </a:r>
+            <a:r>
+              <a:rPr lang="de-DE" dirty="0" err="1"/>
+              <a:t>Therefore</a:t>
+            </a:r>
+            <a:r>
+              <a:rPr lang="de-DE" dirty="0"/>
+              <a:t>, </a:t>
+            </a:r>
+            <a:r>
+              <a:rPr lang="de-DE" dirty="0" err="1"/>
+              <a:t>you</a:t>
+            </a:r>
+            <a:r>
+              <a:rPr lang="de-DE" dirty="0"/>
+              <a:t> </a:t>
+            </a:r>
+            <a:r>
+              <a:rPr lang="de-DE" dirty="0" err="1"/>
+              <a:t>should</a:t>
+            </a:r>
+            <a:r>
+              <a:rPr lang="de-DE" dirty="0"/>
+              <a:t> </a:t>
+            </a:r>
+            <a:r>
+              <a:rPr lang="de-DE" dirty="0" err="1"/>
+              <a:t>cross-reference</a:t>
+            </a:r>
+            <a:r>
+              <a:rPr lang="de-DE" dirty="0"/>
+              <a:t> and </a:t>
+            </a:r>
+            <a:r>
+              <a:rPr lang="de-DE" dirty="0" err="1"/>
+              <a:t>map</a:t>
+            </a:r>
+            <a:r>
+              <a:rPr lang="de-DE" dirty="0"/>
+              <a:t> </a:t>
+            </a:r>
+            <a:r>
+              <a:rPr lang="de-DE" dirty="0" err="1"/>
+              <a:t>them</a:t>
+            </a:r>
+            <a:r>
+              <a:rPr lang="de-DE" dirty="0"/>
+              <a:t> </a:t>
+            </a:r>
+            <a:r>
+              <a:rPr lang="de-DE" dirty="0" err="1"/>
+              <a:t>accordingly</a:t>
+            </a:r>
+            <a:r>
+              <a:rPr lang="de-DE" dirty="0"/>
+              <a:t> via </a:t>
+            </a:r>
+            <a:r>
+              <a:rPr lang="de-DE" dirty="0" err="1"/>
+              <a:t>their</a:t>
+            </a:r>
+            <a:r>
+              <a:rPr lang="de-DE" dirty="0"/>
+              <a:t> </a:t>
+            </a:r>
+            <a:r>
+              <a:rPr lang="de-DE" dirty="0" err="1"/>
+              <a:t>unique</a:t>
+            </a:r>
+            <a:r>
+              <a:rPr lang="de-DE" dirty="0"/>
+              <a:t> </a:t>
+            </a:r>
+            <a:r>
+              <a:rPr lang="de-DE" dirty="0" err="1"/>
+              <a:t>filename</a:t>
+            </a:r>
+            <a:r>
+              <a:rPr lang="de-DE" dirty="0"/>
+              <a:t>.</a:t>
+            </a:r>
+          </a:p>
+          <a:p>
+            <a:r>
+              <a:rPr lang="de-DE" dirty="0"/>
+              <a:t>For </a:t>
+            </a:r>
+            <a:r>
+              <a:rPr lang="de-DE" dirty="0" err="1"/>
+              <a:t>computational</a:t>
+            </a:r>
+            <a:r>
+              <a:rPr lang="de-DE" dirty="0"/>
+              <a:t> </a:t>
+            </a:r>
+            <a:r>
+              <a:rPr lang="de-DE" dirty="0" err="1"/>
+              <a:t>efficiency</a:t>
+            </a:r>
+            <a:r>
+              <a:rPr lang="de-DE" dirty="0"/>
+              <a:t>, </a:t>
+            </a:r>
+            <a:r>
+              <a:rPr lang="de-DE" dirty="0" err="1"/>
+              <a:t>restrict</a:t>
+            </a:r>
+            <a:r>
+              <a:rPr lang="de-DE" dirty="0"/>
+              <a:t> </a:t>
+            </a:r>
+            <a:r>
+              <a:rPr lang="de-DE" dirty="0" err="1"/>
+              <a:t>your</a:t>
+            </a:r>
+            <a:r>
+              <a:rPr lang="de-DE" dirty="0"/>
+              <a:t> </a:t>
+            </a:r>
+            <a:r>
+              <a:rPr lang="de-DE" dirty="0" err="1"/>
+              <a:t>analysis</a:t>
+            </a:r>
+            <a:r>
+              <a:rPr lang="de-DE" dirty="0"/>
+              <a:t> to the </a:t>
+            </a:r>
+            <a:r>
+              <a:rPr lang="de-DE" dirty="0" err="1"/>
+              <a:t>images</a:t>
+            </a:r>
+            <a:r>
+              <a:rPr lang="de-DE" dirty="0"/>
+              <a:t> </a:t>
+            </a:r>
+            <a:r>
+              <a:rPr lang="de-DE" dirty="0" err="1"/>
+              <a:t>belonging</a:t>
+            </a:r>
+            <a:r>
+              <a:rPr lang="de-DE" dirty="0"/>
+              <a:t> to the </a:t>
+            </a:r>
+            <a:r>
+              <a:rPr lang="de-DE" dirty="0" err="1"/>
+              <a:t>first</a:t>
+            </a:r>
+            <a:r>
+              <a:rPr lang="de-DE" dirty="0"/>
+              <a:t> 100 </a:t>
+            </a:r>
+            <a:r>
+              <a:rPr lang="de-DE" dirty="0" err="1"/>
+              <a:t>classes</a:t>
+            </a:r>
+            <a:r>
+              <a:rPr lang="de-DE" dirty="0"/>
+              <a:t> in </a:t>
+            </a:r>
+            <a:r>
+              <a:rPr lang="de-DE" dirty="0" err="1"/>
+              <a:t>val.csv</a:t>
+            </a:r>
+            <a:r>
+              <a:rPr lang="de-DE" dirty="0"/>
+              <a:t> (</a:t>
+            </a:r>
+            <a:r>
+              <a:rPr lang="de-DE" dirty="0" err="1"/>
+              <a:t>landmark_id</a:t>
+            </a:r>
+            <a:r>
+              <a:rPr lang="de-DE" dirty="0"/>
+              <a:t> 0 to 99). </a:t>
+            </a:r>
+            <a:r>
+              <a:rPr lang="de-DE" dirty="0" err="1"/>
+              <a:t>Apply</a:t>
+            </a:r>
+            <a:r>
+              <a:rPr lang="de-DE" dirty="0"/>
+              <a:t> </a:t>
+            </a:r>
+            <a:r>
+              <a:rPr lang="de-DE" dirty="0" err="1"/>
+              <a:t>this</a:t>
+            </a:r>
+            <a:r>
+              <a:rPr lang="de-DE" dirty="0"/>
+              <a:t> </a:t>
+            </a:r>
+            <a:r>
+              <a:rPr lang="de-DE" dirty="0" err="1"/>
+              <a:t>filter</a:t>
+            </a:r>
+            <a:r>
+              <a:rPr lang="de-DE" dirty="0"/>
+              <a:t> to </a:t>
+            </a:r>
+            <a:r>
+              <a:rPr lang="de-DE" dirty="0" err="1"/>
+              <a:t>both</a:t>
+            </a:r>
+            <a:r>
+              <a:rPr lang="de-DE" dirty="0"/>
+              <a:t> for the </a:t>
+            </a:r>
+            <a:r>
+              <a:rPr lang="de-DE" dirty="0" err="1"/>
+              <a:t>query</a:t>
+            </a:r>
+            <a:r>
+              <a:rPr lang="de-DE" dirty="0"/>
+              <a:t> pool and the </a:t>
+            </a:r>
+            <a:r>
+              <a:rPr lang="de-DE" dirty="0" err="1"/>
+              <a:t>gallery</a:t>
+            </a:r>
+            <a:r>
+              <a:rPr lang="de-DE" dirty="0"/>
+              <a:t> </a:t>
+            </a:r>
+            <a:r>
+              <a:rPr lang="de-DE" dirty="0" err="1"/>
+              <a:t>database</a:t>
+            </a:r>
+            <a:r>
+              <a:rPr lang="de-DE" dirty="0"/>
+              <a:t>.</a:t>
+            </a:r>
+          </a:p>
+          <a:p>
+            <a:pPr lvl="0"/>
+            <a:r>
+              <a:rPr lang="de-DE" dirty="0"/>
+              <a:t>For </a:t>
+            </a:r>
+            <a:r>
+              <a:rPr lang="de-DE" dirty="0" err="1"/>
+              <a:t>each</a:t>
+            </a:r>
+            <a:r>
+              <a:rPr lang="de-DE" dirty="0"/>
+              <a:t> </a:t>
+            </a:r>
+            <a:r>
+              <a:rPr lang="de-DE" dirty="0" err="1"/>
+              <a:t>filtered</a:t>
+            </a:r>
+            <a:r>
+              <a:rPr lang="de-DE" dirty="0"/>
+              <a:t> </a:t>
+            </a:r>
+            <a:r>
+              <a:rPr lang="de-DE" dirty="0" err="1"/>
+              <a:t>query</a:t>
+            </a:r>
+            <a:r>
+              <a:rPr lang="de-DE" dirty="0"/>
+              <a:t> </a:t>
+            </a:r>
+            <a:r>
+              <a:rPr lang="de-DE" dirty="0" err="1"/>
+              <a:t>image</a:t>
+            </a:r>
+            <a:r>
+              <a:rPr lang="de-DE" dirty="0"/>
+              <a:t>, </a:t>
+            </a:r>
+            <a:r>
+              <a:rPr lang="de-DE" dirty="0" err="1"/>
+              <a:t>retrieve</a:t>
+            </a:r>
+            <a:r>
+              <a:rPr lang="de-DE" dirty="0"/>
+              <a:t> the Top-5 </a:t>
+            </a:r>
+            <a:r>
+              <a:rPr lang="de-DE" dirty="0" err="1"/>
+              <a:t>most</a:t>
+            </a:r>
+            <a:r>
+              <a:rPr lang="de-DE" dirty="0"/>
+              <a:t> </a:t>
+            </a:r>
+            <a:r>
+              <a:rPr lang="de-DE" dirty="0" err="1"/>
+              <a:t>similar</a:t>
+            </a:r>
+            <a:r>
+              <a:rPr lang="de-DE" dirty="0"/>
+              <a:t> </a:t>
+            </a:r>
+            <a:r>
+              <a:rPr lang="de-DE" dirty="0" err="1"/>
+              <a:t>gallery</a:t>
+            </a:r>
+            <a:r>
+              <a:rPr lang="de-DE" dirty="0"/>
+              <a:t> </a:t>
+            </a:r>
+            <a:r>
+              <a:rPr lang="de-DE" dirty="0" err="1"/>
+              <a:t>images</a:t>
+            </a:r>
+            <a:r>
+              <a:rPr lang="de-DE" dirty="0"/>
+              <a:t>.</a:t>
+            </a:r>
+          </a:p>
+          <a:p>
+            <a:r>
+              <a:rPr lang="de-DE" dirty="0" err="1"/>
+              <a:t>Calculate</a:t>
+            </a:r>
+            <a:r>
+              <a:rPr lang="de-DE" dirty="0"/>
+              <a:t> the final Top-1 and Top-5  </a:t>
+            </a:r>
+            <a:r>
+              <a:rPr lang="de-DE" dirty="0" err="1"/>
+              <a:t>retrieval</a:t>
+            </a:r>
+            <a:r>
+              <a:rPr lang="de-DE" dirty="0"/>
+              <a:t> </a:t>
+            </a:r>
+            <a:r>
+              <a:rPr lang="de-DE" dirty="0" err="1"/>
+              <a:t>precision</a:t>
+            </a:r>
+            <a:r>
+              <a:rPr lang="de-DE" dirty="0"/>
+              <a:t>.</a:t>
+            </a:r>
+          </a:p>
+        </p:txBody>
+      </p:sp>
+    </p:spTree>
+    <p:extLst>
+      <p:ext uri="{BB962C8B-B14F-4D97-AF65-F5344CB8AC3E}">
+        <p14:creationId xmlns:p14="http://schemas.microsoft.com/office/powerpoint/2010/main" val="4220248417"/>
+      </p:ext>
+    </p:extLst>
+  </p:cSld>
+  <p:clrMapOvr>
+    <a:masterClrMapping/>
+  </p:clrMapOvr>
+</p:sld>
+</file>
+
+<file path=ppt/slides/slide3.xml><?xml version="1.0" encoding="utf-8"?>
+<p:sld xmlns:a="http://schemas.openxmlformats.org/drawingml/2006/main" xmlns:r="http://schemas.openxmlformats.org/officeDocument/2006/relationships" xmlns:p="http://schemas.openxmlformats.org/presentationml/2006/main">
+  <p:cSld>
+    <p:spTree>
+      <p:nvGrpSpPr>
+        <p:cNvPr id="1" name="">
+          <a:extLst>
+            <a:ext uri="{FF2B5EF4-FFF2-40B4-BE49-F238E27FC236}">
+              <a16:creationId xmlns:a16="http://schemas.microsoft.com/office/drawing/2014/main" id="{6C485F38-D6CA-7064-932E-92C69AC30093}"/>
+            </a:ext>
+          </a:extLst>
+        </p:cNvPr>
+        <p:cNvGrpSpPr/>
+        <p:nvPr/>
+      </p:nvGrpSpPr>
+      <p:grpSpPr>
+        <a:xfrm>
+          <a:off x="0" y="0"/>
+          <a:ext cx="0" cy="0"/>
+          <a:chOff x="0" y="0"/>
+          <a:chExt cx="0" cy="0"/>
+        </a:xfrm>
+      </p:grpSpPr>
+      <p:sp>
+        <p:nvSpPr>
+          <p:cNvPr id="2" name="Titel 1">
+            <a:extLst>
+              <a:ext uri="{FF2B5EF4-FFF2-40B4-BE49-F238E27FC236}">
+                <a16:creationId xmlns:a16="http://schemas.microsoft.com/office/drawing/2014/main" id="{263379EF-5084-E6DF-7ED0-47C4EA6AA718}"/>
+              </a:ext>
+            </a:extLst>
+          </p:cNvPr>
+          <p:cNvSpPr>
+            <a:spLocks noGrp="1"/>
+          </p:cNvSpPr>
+          <p:nvPr>
+            <p:ph type="title"/>
+          </p:nvPr>
+        </p:nvSpPr>
+        <p:spPr/>
+        <p:txBody>
+          <a:bodyPr/>
+          <a:lstStyle/>
+          <a:p>
+            <a:r>
+              <a:rPr lang="de-DE" dirty="0"/>
+              <a:t>Project 3</a:t>
+            </a:r>
+          </a:p>
+        </p:txBody>
+      </p:sp>
+      <p:sp>
+        <p:nvSpPr>
+          <p:cNvPr id="3" name="Inhaltsplatzhalter 2">
+            <a:extLst>
+              <a:ext uri="{FF2B5EF4-FFF2-40B4-BE49-F238E27FC236}">
+                <a16:creationId xmlns:a16="http://schemas.microsoft.com/office/drawing/2014/main" id="{95499B61-62B2-2CEA-3C91-84A8B1A45AA2}"/>
+              </a:ext>
+            </a:extLst>
+          </p:cNvPr>
+          <p:cNvSpPr>
+            <a:spLocks noGrp="1"/>
+          </p:cNvSpPr>
+          <p:nvPr>
+            <p:ph idx="1"/>
+          </p:nvPr>
+        </p:nvSpPr>
+        <p:spPr/>
+        <p:txBody>
+          <a:bodyPr>
+            <a:normAutofit/>
+          </a:bodyPr>
+          <a:lstStyle/>
+          <a:p>
+            <a:pPr marL="0" indent="0" algn="ctr">
+              <a:buNone/>
+            </a:pPr>
+            <a:endParaRPr lang="de-DE" sz="5000" dirty="0"/>
+          </a:p>
+          <a:p>
+            <a:pPr marL="0" indent="0" algn="ctr">
+              <a:buNone/>
+            </a:pPr>
+            <a:endParaRPr lang="de-DE" sz="5000" dirty="0">
+              <a:hlinkClick r:id="rId2"/>
+            </a:endParaRPr>
+          </a:p>
+          <a:p>
+            <a:pPr marL="0" indent="0" algn="ctr">
+              <a:buNone/>
+            </a:pPr>
+            <a:r>
+              <a:rPr lang="de-DE" sz="5000" dirty="0">
+                <a:hlinkClick r:id="rId2"/>
+              </a:rPr>
+              <a:t>Dogs vs. Cats</a:t>
+            </a:r>
+            <a:endParaRPr lang="de-DE" sz="5000" dirty="0"/>
+          </a:p>
+        </p:txBody>
+      </p:sp>
+    </p:spTree>
+    <p:extLst>
+      <p:ext uri="{BB962C8B-B14F-4D97-AF65-F5344CB8AC3E}">
+        <p14:creationId xmlns:p14="http://schemas.microsoft.com/office/powerpoint/2010/main" val="3663950801"/>
+      </p:ext>
+    </p:extLst>
+  </p:cSld>
+  <p:clrMapOvr>
+    <a:masterClrMapping/>
+  </p:clrMapOvr>
+</p:sld>
+</file>
+
+<file path=ppt/slides/slide4.xml><?xml version="1.0" encoding="utf-8"?>
+<p:sld xmlns:a="http://schemas.openxmlformats.org/drawingml/2006/main" xmlns:r="http://schemas.openxmlformats.org/officeDocument/2006/relationships" xmlns:p="http://schemas.openxmlformats.org/presentationml/2006/main">
+  <p:cSld>
+    <p:spTree>
+      <p:nvGrpSpPr>
+        <p:cNvPr id="1" name="">
+          <a:extLst>
+            <a:ext uri="{FF2B5EF4-FFF2-40B4-BE49-F238E27FC236}">
+              <a16:creationId xmlns:a16="http://schemas.microsoft.com/office/drawing/2014/main" id="{3A33991C-82A0-B914-7306-4B060B407632}"/>
+            </a:ext>
+          </a:extLst>
+        </p:cNvPr>
+        <p:cNvGrpSpPr/>
+        <p:nvPr/>
+      </p:nvGrpSpPr>
+      <p:grpSpPr>
+        <a:xfrm>
+          <a:off x="0" y="0"/>
+          <a:ext cx="0" cy="0"/>
+          <a:chOff x="0" y="0"/>
+          <a:chExt cx="0" cy="0"/>
+        </a:xfrm>
+      </p:grpSpPr>
+      <p:sp>
+        <p:nvSpPr>
+          <p:cNvPr id="2" name="Titel 1">
+            <a:extLst>
+              <a:ext uri="{FF2B5EF4-FFF2-40B4-BE49-F238E27FC236}">
+                <a16:creationId xmlns:a16="http://schemas.microsoft.com/office/drawing/2014/main" id="{2CDD0C51-416C-C5EE-4E3F-2E7ACC6F82CC}"/>
+              </a:ext>
+            </a:extLst>
+          </p:cNvPr>
+          <p:cNvSpPr>
+            <a:spLocks noGrp="1"/>
+          </p:cNvSpPr>
+          <p:nvPr>
+            <p:ph type="title"/>
+          </p:nvPr>
+        </p:nvSpPr>
+        <p:spPr/>
+        <p:txBody>
+          <a:bodyPr/>
+          <a:lstStyle/>
+          <a:p>
+            <a:r>
+              <a:rPr lang="de-DE" dirty="0"/>
+              <a:t>Project 4</a:t>
+            </a:r>
+          </a:p>
+        </p:txBody>
+      </p:sp>
+      <p:sp>
+        <p:nvSpPr>
+          <p:cNvPr id="3" name="Inhaltsplatzhalter 2">
+            <a:extLst>
+              <a:ext uri="{FF2B5EF4-FFF2-40B4-BE49-F238E27FC236}">
+                <a16:creationId xmlns:a16="http://schemas.microsoft.com/office/drawing/2014/main" id="{BB0B091C-321A-EEED-80F5-511C8FF3BD04}"/>
+              </a:ext>
+            </a:extLst>
+          </p:cNvPr>
+          <p:cNvSpPr>
+            <a:spLocks noGrp="1"/>
+          </p:cNvSpPr>
+          <p:nvPr>
+            <p:ph idx="1"/>
+          </p:nvPr>
+        </p:nvSpPr>
+        <p:spPr/>
+        <p:txBody>
+          <a:bodyPr>
+            <a:normAutofit/>
+          </a:bodyPr>
+          <a:lstStyle/>
+          <a:p>
+            <a:pPr marL="0" indent="0" algn="ctr">
+              <a:buNone/>
+            </a:pPr>
+            <a:endParaRPr lang="de-DE" sz="5000" dirty="0"/>
+          </a:p>
+          <a:p>
+            <a:pPr marL="0" indent="0" algn="ctr">
+              <a:buNone/>
+            </a:pPr>
+            <a:endParaRPr lang="de-DE" sz="5000" dirty="0">
+              <a:hlinkClick r:id="rId2"/>
+            </a:endParaRPr>
+          </a:p>
+          <a:p>
+            <a:pPr marL="0" indent="0" algn="ctr">
+              <a:buNone/>
+            </a:pPr>
+            <a:r>
+              <a:rPr lang="de-DE" sz="5000" dirty="0">
+                <a:hlinkClick r:id="rId2"/>
+              </a:rPr>
+              <a:t>Natural Scene Classification</a:t>
+            </a:r>
+            <a:endParaRPr lang="de-DE" sz="5000" dirty="0"/>
+          </a:p>
+        </p:txBody>
+      </p:sp>
+    </p:spTree>
+    <p:extLst>
+      <p:ext uri="{BB962C8B-B14F-4D97-AF65-F5344CB8AC3E}">
+        <p14:creationId xmlns:p14="http://schemas.microsoft.com/office/powerpoint/2010/main" val="3312599535"/>
+      </p:ext>
+    </p:extLst>
+  </p:cSld>
+  <p:clrMapOvr>
+    <a:masterClrMapping/>
+  </p:clrMapOvr>
+</p:sld>
+</file>
+
+<file path=ppt/slides/slide5.xml><?xml version="1.0" encoding="utf-8"?>
+<p:sld xmlns:a="http://schemas.openxmlformats.org/drawingml/2006/main" xmlns:r="http://schemas.openxmlformats.org/officeDocument/2006/relationships" xmlns:p="http://schemas.openxmlformats.org/presentationml/2006/main">
+  <p:cSld>
+    <p:spTree>
+      <p:nvGrpSpPr>
+        <p:cNvPr id="1" name="">
+          <a:extLst>
+            <a:ext uri="{FF2B5EF4-FFF2-40B4-BE49-F238E27FC236}">
+              <a16:creationId xmlns:a16="http://schemas.microsoft.com/office/drawing/2014/main" id="{5B337196-24F8-E28E-33B0-A516B3DF34AC}"/>
+            </a:ext>
+          </a:extLst>
+        </p:cNvPr>
+        <p:cNvGrpSpPr/>
+        <p:nvPr/>
+      </p:nvGrpSpPr>
+      <p:grpSpPr>
+        <a:xfrm>
+          <a:off x="0" y="0"/>
+          <a:ext cx="0" cy="0"/>
+          <a:chOff x="0" y="0"/>
+          <a:chExt cx="0" cy="0"/>
+        </a:xfrm>
+      </p:grpSpPr>
+      <p:sp>
+        <p:nvSpPr>
+          <p:cNvPr id="2" name="Titel 1">
+            <a:extLst>
+              <a:ext uri="{FF2B5EF4-FFF2-40B4-BE49-F238E27FC236}">
+                <a16:creationId xmlns:a16="http://schemas.microsoft.com/office/drawing/2014/main" id="{59EBF755-03A6-10C2-DD84-2085E46348E7}"/>
+              </a:ext>
+            </a:extLst>
+          </p:cNvPr>
+          <p:cNvSpPr>
+            <a:spLocks noGrp="1"/>
+          </p:cNvSpPr>
+          <p:nvPr>
+            <p:ph type="title"/>
+          </p:nvPr>
+        </p:nvSpPr>
+        <p:spPr/>
+        <p:txBody>
+          <a:bodyPr/>
+          <a:lstStyle/>
+          <a:p>
+            <a:r>
+              <a:rPr lang="de-DE" dirty="0"/>
+              <a:t>Project 5</a:t>
+            </a:r>
+          </a:p>
+        </p:txBody>
+      </p:sp>
+      <p:sp>
+        <p:nvSpPr>
+          <p:cNvPr id="3" name="Inhaltsplatzhalter 2">
+            <a:extLst>
+              <a:ext uri="{FF2B5EF4-FFF2-40B4-BE49-F238E27FC236}">
+                <a16:creationId xmlns:a16="http://schemas.microsoft.com/office/drawing/2014/main" id="{228CA356-43A5-C784-3BD1-A9EB611B7301}"/>
+              </a:ext>
+            </a:extLst>
+          </p:cNvPr>
+          <p:cNvSpPr>
+            <a:spLocks noGrp="1"/>
+          </p:cNvSpPr>
+          <p:nvPr>
+            <p:ph idx="1"/>
+          </p:nvPr>
+        </p:nvSpPr>
+        <p:spPr/>
+        <p:txBody>
+          <a:bodyPr>
+            <a:normAutofit/>
+          </a:bodyPr>
+          <a:lstStyle/>
+          <a:p>
+            <a:pPr marL="0" indent="0" algn="ctr">
+              <a:buNone/>
+            </a:pPr>
+            <a:endParaRPr lang="de-DE" sz="5000" dirty="0"/>
+          </a:p>
+          <a:p>
+            <a:pPr marL="0" indent="0" algn="ctr">
+              <a:buNone/>
+            </a:pPr>
+            <a:endParaRPr lang="de-DE" sz="5000" dirty="0">
+              <a:hlinkClick r:id="rId2"/>
+            </a:endParaRPr>
+          </a:p>
+          <a:p>
+            <a:pPr marL="0" indent="0" algn="ctr">
+              <a:buNone/>
+            </a:pPr>
+            <a:r>
+              <a:rPr lang="de-DE" sz="5000" dirty="0">
+                <a:hlinkClick r:id="rId2"/>
+              </a:rPr>
+              <a:t>Real or Generated</a:t>
+            </a:r>
+            <a:endParaRPr lang="de-DE" sz="5000" dirty="0"/>
+          </a:p>
+        </p:txBody>
+      </p:sp>
+    </p:spTree>
+    <p:extLst>
+      <p:ext uri="{BB962C8B-B14F-4D97-AF65-F5344CB8AC3E}">
+        <p14:creationId xmlns:p14="http://schemas.microsoft.com/office/powerpoint/2010/main" val="2810437318"/>
+      </p:ext>
+    </p:extLst>
+  </p:cSld>
+  <p:clrMapOvr>
+    <a:masterClrMapping/>
+  </p:clrMapOvr>
+</p:sld>
+</file>
+
+<file path=ppt/slides/slide6.xml><?xml version="1.0" encoding="utf-8"?>
+<p:sld xmlns:a="http://schemas.openxmlformats.org/drawingml/2006/main" xmlns:r="http://schemas.openxmlformats.org/officeDocument/2006/relationships" xmlns:p="http://schemas.openxmlformats.org/presentationml/2006/main">
+  <p:cSld>
+    <p:spTree>
+      <p:nvGrpSpPr>
+        <p:cNvPr id="1" name=""/>
+        <p:cNvGrpSpPr/>
+        <p:nvPr/>
+      </p:nvGrpSpPr>
+      <p:grpSpPr>
+        <a:xfrm>
+          <a:off x="0" y="0"/>
+          <a:ext cx="0" cy="0"/>
+          <a:chOff x="0" y="0"/>
+          <a:chExt cx="0" cy="0"/>
+        </a:xfrm>
+      </p:grpSpPr>
+      <p:sp>
+        <p:nvSpPr>
+          <p:cNvPr id="2" name="Titel 1">
+            <a:extLst>
+              <a:ext uri="{FF2B5EF4-FFF2-40B4-BE49-F238E27FC236}">
+                <a16:creationId xmlns:a16="http://schemas.microsoft.com/office/drawing/2014/main" id="{B36A56C2-F2B3-C368-7E17-D99DEC298454}"/>
+              </a:ext>
+            </a:extLst>
+          </p:cNvPr>
+          <p:cNvSpPr>
+            <a:spLocks noGrp="1"/>
+          </p:cNvSpPr>
+          <p:nvPr>
+            <p:ph type="title"/>
+          </p:nvPr>
+        </p:nvSpPr>
+        <p:spPr/>
+        <p:txBody>
+          <a:bodyPr/>
+          <a:lstStyle/>
+          <a:p>
+            <a:r>
+              <a:rPr lang="de-DE" dirty="0"/>
+              <a:t>Project 6</a:t>
+            </a:r>
+          </a:p>
+        </p:txBody>
+      </p:sp>
+      <p:sp>
+        <p:nvSpPr>
+          <p:cNvPr id="3" name="Inhaltsplatzhalter 2">
+            <a:extLst>
+              <a:ext uri="{FF2B5EF4-FFF2-40B4-BE49-F238E27FC236}">
+                <a16:creationId xmlns:a16="http://schemas.microsoft.com/office/drawing/2014/main" id="{9274D432-B0FA-CB2B-BFE2-F35E81B74008}"/>
+              </a:ext>
+            </a:extLst>
+          </p:cNvPr>
+          <p:cNvSpPr>
+            <a:spLocks noGrp="1"/>
+          </p:cNvSpPr>
+          <p:nvPr>
+            <p:ph idx="1"/>
+          </p:nvPr>
+        </p:nvSpPr>
+        <p:spPr/>
+        <p:txBody>
+          <a:bodyPr>
+            <a:normAutofit/>
+          </a:bodyPr>
+          <a:lstStyle/>
+          <a:p>
+            <a:pPr marL="0" indent="0" algn="ctr">
+              <a:buNone/>
+            </a:pPr>
+            <a:endParaRPr lang="de-DE" sz="5000" dirty="0"/>
+          </a:p>
+          <a:p>
+            <a:pPr marL="0" indent="0" algn="ctr">
+              <a:buNone/>
+            </a:pPr>
+            <a:endParaRPr lang="de-DE" sz="5000" dirty="0">
+              <a:hlinkClick r:id="rId2"/>
+            </a:endParaRPr>
+          </a:p>
+          <a:p>
+            <a:pPr marL="0" indent="0" algn="ctr">
+              <a:buNone/>
+            </a:pPr>
+            <a:r>
+              <a:rPr lang="de-DE" sz="5000" dirty="0">
+                <a:hlinkClick r:id="rId2"/>
+              </a:rPr>
+              <a:t>Leaf Classification</a:t>
+            </a:r>
+            <a:endParaRPr lang="de-DE" sz="5000" dirty="0"/>
+          </a:p>
+        </p:txBody>
+      </p:sp>
+    </p:spTree>
+    <p:extLst>
+      <p:ext uri="{BB962C8B-B14F-4D97-AF65-F5344CB8AC3E}">
+        <p14:creationId xmlns:p14="http://schemas.microsoft.com/office/powerpoint/2010/main" val="3021455303"/>
+      </p:ext>
+    </p:extLst>
+  </p:cSld>
+  <p:clrMapOvr>
+    <a:masterClrMapping/>
+  </p:clrMapOvr>
+</p:sld>
+</file>
+
+<file path=ppt/slides/slide7.xml><?xml version="1.0" encoding="utf-8"?>
+<p:sld xmlns:a="http://schemas.openxmlformats.org/drawingml/2006/main" xmlns:r="http://schemas.openxmlformats.org/officeDocument/2006/relationships" xmlns:p="http://schemas.openxmlformats.org/presentationml/2006/main">
+  <p:cSld>
+    <p:spTree>
+      <p:nvGrpSpPr>
+        <p:cNvPr id="1" name="">
+          <a:extLst>
+            <a:ext uri="{FF2B5EF4-FFF2-40B4-BE49-F238E27FC236}">
+              <a16:creationId xmlns:a16="http://schemas.microsoft.com/office/drawing/2014/main" id="{FA00803C-B780-09A2-08E0-C620A6CE51C5}"/>
+            </a:ext>
+          </a:extLst>
+        </p:cNvPr>
+        <p:cNvGrpSpPr/>
+        <p:nvPr/>
+      </p:nvGrpSpPr>
+      <p:grpSpPr>
+        <a:xfrm>
+          <a:off x="0" y="0"/>
+          <a:ext cx="0" cy="0"/>
+          <a:chOff x="0" y="0"/>
+          <a:chExt cx="0" cy="0"/>
+        </a:xfrm>
+      </p:grpSpPr>
+      <p:sp>
+        <p:nvSpPr>
+          <p:cNvPr id="2" name="Titel 1">
+            <a:extLst>
+              <a:ext uri="{FF2B5EF4-FFF2-40B4-BE49-F238E27FC236}">
+                <a16:creationId xmlns:a16="http://schemas.microsoft.com/office/drawing/2014/main" id="{7D5AF378-539B-2EBF-A2F0-B5EA4302E5FC}"/>
+              </a:ext>
+            </a:extLst>
+          </p:cNvPr>
+          <p:cNvSpPr>
+            <a:spLocks noGrp="1"/>
+          </p:cNvSpPr>
+          <p:nvPr>
+            <p:ph type="title"/>
+          </p:nvPr>
+        </p:nvSpPr>
+        <p:spPr/>
+        <p:txBody>
+          <a:bodyPr/>
+          <a:lstStyle/>
+          <a:p>
+            <a:r>
+              <a:rPr lang="de-DE" dirty="0"/>
+              <a:t>Project 7</a:t>
+            </a:r>
+          </a:p>
+        </p:txBody>
+      </p:sp>
+      <p:sp>
+        <p:nvSpPr>
+          <p:cNvPr id="3" name="Inhaltsplatzhalter 2">
+            <a:extLst>
+              <a:ext uri="{FF2B5EF4-FFF2-40B4-BE49-F238E27FC236}">
+                <a16:creationId xmlns:a16="http://schemas.microsoft.com/office/drawing/2014/main" id="{DF4ABE68-D640-0211-011F-A8D9D242A2D7}"/>
+              </a:ext>
+            </a:extLst>
+          </p:cNvPr>
+          <p:cNvSpPr>
+            <a:spLocks noGrp="1"/>
+          </p:cNvSpPr>
+          <p:nvPr>
+            <p:ph idx="1"/>
+          </p:nvPr>
+        </p:nvSpPr>
+        <p:spPr/>
+        <p:txBody>
+          <a:bodyPr>
+            <a:normAutofit/>
+          </a:bodyPr>
+          <a:lstStyle/>
+          <a:p>
+            <a:pPr marL="0" indent="0" algn="ctr">
+              <a:buNone/>
+            </a:pPr>
+            <a:endParaRPr lang="de-DE" sz="5000" dirty="0"/>
+          </a:p>
+          <a:p>
+            <a:pPr marL="0" indent="0" algn="ctr">
+              <a:buNone/>
+            </a:pPr>
+            <a:endParaRPr lang="de-DE" sz="5000" dirty="0">
+              <a:hlinkClick r:id="rId2"/>
+            </a:endParaRPr>
+          </a:p>
+          <a:p>
+            <a:pPr marL="0" indent="0" algn="ctr">
+              <a:buNone/>
+            </a:pPr>
+            <a:r>
+              <a:rPr lang="de-DE" sz="5000" dirty="0">
+                <a:hlinkClick r:id="rId2"/>
+              </a:rPr>
+              <a:t>Face Identification</a:t>
+            </a:r>
+            <a:endParaRPr lang="de-DE" sz="5000" dirty="0"/>
+          </a:p>
+        </p:txBody>
+      </p:sp>
+    </p:spTree>
+    <p:extLst>
+      <p:ext uri="{BB962C8B-B14F-4D97-AF65-F5344CB8AC3E}">
+        <p14:creationId xmlns:p14="http://schemas.microsoft.com/office/powerpoint/2010/main" val="677040233"/>
+      </p:ext>
+    </p:extLst>
+  </p:cSld>
+  <p:clrMapOvr>
+    <a:masterClrMapping/>
+  </p:clrMapOvr>
+</p:sld>
+</file>
+
+<file path=ppt/slides/slide8.xml><?xml version="1.0" encoding="utf-8"?>
+<p:sld xmlns:a="http://schemas.openxmlformats.org/drawingml/2006/main" xmlns:r="http://schemas.openxmlformats.org/officeDocument/2006/relationships" xmlns:p="http://schemas.openxmlformats.org/presentationml/2006/main">
+  <p:cSld>
+    <p:spTree>
+      <p:nvGrpSpPr>
+        <p:cNvPr id="1" name="">
+          <a:extLst>
+            <a:ext uri="{FF2B5EF4-FFF2-40B4-BE49-F238E27FC236}">
+              <a16:creationId xmlns:a16="http://schemas.microsoft.com/office/drawing/2014/main" id="{E1586526-30AD-DA3B-7876-1143915CF3FD}"/>
+            </a:ext>
+          </a:extLst>
+        </p:cNvPr>
+        <p:cNvGrpSpPr/>
+        <p:nvPr/>
+      </p:nvGrpSpPr>
+      <p:grpSpPr>
+        <a:xfrm>
+          <a:off x="0" y="0"/>
+          <a:ext cx="0" cy="0"/>
+          <a:chOff x="0" y="0"/>
+          <a:chExt cx="0" cy="0"/>
+        </a:xfrm>
+      </p:grpSpPr>
+      <p:sp>
+        <p:nvSpPr>
+          <p:cNvPr id="2" name="Titel 1">
+            <a:extLst>
+              <a:ext uri="{FF2B5EF4-FFF2-40B4-BE49-F238E27FC236}">
+                <a16:creationId xmlns:a16="http://schemas.microsoft.com/office/drawing/2014/main" id="{1056B9C7-BB8D-5EB8-FAB0-4352B95AF214}"/>
+              </a:ext>
+            </a:extLst>
+          </p:cNvPr>
+          <p:cNvSpPr>
+            <a:spLocks noGrp="1"/>
+          </p:cNvSpPr>
+          <p:nvPr>
+            <p:ph type="title"/>
+          </p:nvPr>
+        </p:nvSpPr>
+        <p:spPr/>
+        <p:txBody>
+          <a:bodyPr/>
+          <a:lstStyle/>
+          <a:p>
+            <a:r>
+              <a:rPr lang="de-DE" dirty="0"/>
+              <a:t>Project 8</a:t>
+            </a:r>
+          </a:p>
+        </p:txBody>
+      </p:sp>
+      <p:sp>
+        <p:nvSpPr>
+          <p:cNvPr id="3" name="Inhaltsplatzhalter 2">
+            <a:extLst>
+              <a:ext uri="{FF2B5EF4-FFF2-40B4-BE49-F238E27FC236}">
+                <a16:creationId xmlns:a16="http://schemas.microsoft.com/office/drawing/2014/main" id="{DFA763C2-80FD-FCB2-8224-74624E0B1848}"/>
+              </a:ext>
+            </a:extLst>
+          </p:cNvPr>
+          <p:cNvSpPr>
+            <a:spLocks noGrp="1"/>
+          </p:cNvSpPr>
+          <p:nvPr>
+            <p:ph idx="1"/>
+          </p:nvPr>
+        </p:nvSpPr>
+        <p:spPr/>
+        <p:txBody>
+          <a:bodyPr>
+            <a:normAutofit/>
+          </a:bodyPr>
+          <a:lstStyle/>
+          <a:p>
+            <a:pPr marL="0" indent="0" algn="ctr">
+              <a:buNone/>
+            </a:pPr>
+            <a:endParaRPr lang="de-DE" sz="5000" dirty="0"/>
+          </a:p>
+          <a:p>
+            <a:pPr marL="0" indent="0" algn="ctr">
+              <a:buNone/>
+            </a:pPr>
+            <a:endParaRPr lang="de-DE" sz="5000" dirty="0">
+              <a:hlinkClick r:id="rId2"/>
+            </a:endParaRPr>
+          </a:p>
+          <a:p>
+            <a:pPr marL="0" indent="0" algn="ctr">
+              <a:buNone/>
+            </a:pPr>
+            <a:r>
+              <a:rPr lang="de-DE" sz="5000" dirty="0">
+                <a:hlinkClick r:id="rId2"/>
+              </a:rPr>
+              <a:t>Medical Image Segmentation</a:t>
+            </a:r>
+            <a:endParaRPr lang="de-DE" sz="5000" dirty="0"/>
+          </a:p>
+        </p:txBody>
+      </p:sp>
+    </p:spTree>
+    <p:extLst>
+      <p:ext uri="{BB962C8B-B14F-4D97-AF65-F5344CB8AC3E}">
+        <p14:creationId xmlns:p14="http://schemas.microsoft.com/office/powerpoint/2010/main" val="311497940"/>
+      </p:ext>
+    </p:extLst>
+  </p:cSld>
+  <p:clrMapOvr>
+    <a:masterClrMapping/>
+  </p:clrMapOvr>
+</p:sld>
+</file>
+
+<file path=ppt/slides/slide9.xml><?xml version="1.0" encoding="utf-8"?>
 <p:sld xmlns:a="http://schemas.openxmlformats.org/drawingml/2006/main" xmlns:r="http://schemas.openxmlformats.org/officeDocument/2006/relationships" xmlns:p="http://schemas.openxmlformats.org/presentationml/2006/main">
   <p:cSld>
     <p:spTree>
@@ -3611,7 +5435,7 @@
           <a:p>
             <a:r>
               <a:rPr lang="de-DE" dirty="0"/>
-              <a:t>Project 3: Group 2</a:t>
+              <a:t>Project 9</a:t>
             </a:r>
           </a:p>
         </p:txBody>
@@ -3648,14 +5472,9 @@
             <a:pPr marL="0" indent="0" algn="ctr">
               <a:buNone/>
             </a:pPr>
-            <a:r>
-              <a:rPr lang="de-DE" sz="5000" dirty="0" err="1"/>
-              <a:t>Kaggle</a:t>
-            </a:r>
-            <a:r>
-              <a:rPr lang="de-DE" sz="5000" dirty="0"/>
-              <a:t>:</a:t>
-            </a:r>
+            <a:endParaRPr lang="de-DE" sz="5000" dirty="0">
+              <a:hlinkClick r:id="rId2"/>
+            </a:endParaRPr>
           </a:p>
           <a:p>
             <a:pPr marL="0" indent="0" algn="ctr">
@@ -3675,1729 +5494,6 @@
     <p:extLst>
       <p:ext uri="{BB962C8B-B14F-4D97-AF65-F5344CB8AC3E}">
         <p14:creationId xmlns:p14="http://schemas.microsoft.com/office/powerpoint/2010/main" val="4277363050"/>
-      </p:ext>
-    </p:extLst>
-  </p:cSld>
-  <p:clrMapOvr>
-    <a:masterClrMapping/>
-  </p:clrMapOvr>
-</p:sld>
-</file>
-
-<file path=ppt/slides/slide11.xml><?xml version="1.0" encoding="utf-8"?>
-<p:sld xmlns:a="http://schemas.openxmlformats.org/drawingml/2006/main" xmlns:r="http://schemas.openxmlformats.org/officeDocument/2006/relationships" xmlns:p="http://schemas.openxmlformats.org/presentationml/2006/main">
-  <p:cSld>
-    <p:spTree>
-      <p:nvGrpSpPr>
-        <p:cNvPr id="1" name="">
-          <a:extLst>
-            <a:ext uri="{FF2B5EF4-FFF2-40B4-BE49-F238E27FC236}">
-              <a16:creationId xmlns:a16="http://schemas.microsoft.com/office/drawing/2014/main" id="{37AA4DEC-E6EA-8DF2-B8BC-466413A3C89A}"/>
-            </a:ext>
-          </a:extLst>
-        </p:cNvPr>
-        <p:cNvGrpSpPr/>
-        <p:nvPr/>
-      </p:nvGrpSpPr>
-      <p:grpSpPr>
-        <a:xfrm>
-          <a:off x="0" y="0"/>
-          <a:ext cx="0" cy="0"/>
-          <a:chOff x="0" y="0"/>
-          <a:chExt cx="0" cy="0"/>
-        </a:xfrm>
-      </p:grpSpPr>
-      <p:sp>
-        <p:nvSpPr>
-          <p:cNvPr id="2" name="Titel 1">
-            <a:extLst>
-              <a:ext uri="{FF2B5EF4-FFF2-40B4-BE49-F238E27FC236}">
-                <a16:creationId xmlns:a16="http://schemas.microsoft.com/office/drawing/2014/main" id="{6B0CA98E-420F-4198-5AAD-D0C7B0099F39}"/>
-              </a:ext>
-            </a:extLst>
-          </p:cNvPr>
-          <p:cNvSpPr>
-            <a:spLocks noGrp="1"/>
-          </p:cNvSpPr>
-          <p:nvPr>
-            <p:ph type="title"/>
-          </p:nvPr>
-        </p:nvSpPr>
-        <p:spPr/>
-        <p:txBody>
-          <a:bodyPr/>
-          <a:lstStyle/>
-          <a:p>
-            <a:r>
-              <a:rPr lang="de-DE" dirty="0"/>
-              <a:t>Project 3: Group 3</a:t>
-            </a:r>
-          </a:p>
-        </p:txBody>
-      </p:sp>
-      <p:sp>
-        <p:nvSpPr>
-          <p:cNvPr id="3" name="Inhaltsplatzhalter 2">
-            <a:extLst>
-              <a:ext uri="{FF2B5EF4-FFF2-40B4-BE49-F238E27FC236}">
-                <a16:creationId xmlns:a16="http://schemas.microsoft.com/office/drawing/2014/main" id="{926DF603-70FC-D4F1-72F2-C28983AE2ACA}"/>
-              </a:ext>
-            </a:extLst>
-          </p:cNvPr>
-          <p:cNvSpPr>
-            <a:spLocks noGrp="1"/>
-          </p:cNvSpPr>
-          <p:nvPr>
-            <p:ph idx="1"/>
-          </p:nvPr>
-        </p:nvSpPr>
-        <p:spPr/>
-        <p:txBody>
-          <a:bodyPr>
-            <a:normAutofit/>
-          </a:bodyPr>
-          <a:lstStyle/>
-          <a:p>
-            <a:pPr marL="0" indent="0" algn="ctr">
-              <a:buNone/>
-            </a:pPr>
-            <a:endParaRPr lang="de-DE" sz="5000" dirty="0"/>
-          </a:p>
-          <a:p>
-            <a:pPr marL="0" indent="0" algn="ctr">
-              <a:buNone/>
-            </a:pPr>
-            <a:r>
-              <a:rPr lang="de-DE" sz="5000" dirty="0" err="1"/>
-              <a:t>Kaggle</a:t>
-            </a:r>
-            <a:r>
-              <a:rPr lang="de-DE" sz="5000" dirty="0"/>
-              <a:t>:</a:t>
-            </a:r>
-          </a:p>
-          <a:p>
-            <a:pPr marL="0" indent="0" algn="ctr">
-              <a:buNone/>
-            </a:pPr>
-            <a:r>
-              <a:rPr lang="de-DE" sz="5000" dirty="0">
-                <a:hlinkClick r:id="rId2"/>
-              </a:rPr>
-              <a:t>Fruit Detection</a:t>
-            </a:r>
-            <a:endParaRPr lang="de-DE" sz="5000" dirty="0"/>
-          </a:p>
-        </p:txBody>
-      </p:sp>
-    </p:spTree>
-    <p:extLst>
-      <p:ext uri="{BB962C8B-B14F-4D97-AF65-F5344CB8AC3E}">
-        <p14:creationId xmlns:p14="http://schemas.microsoft.com/office/powerpoint/2010/main" val="607152652"/>
-      </p:ext>
-    </p:extLst>
-  </p:cSld>
-  <p:clrMapOvr>
-    <a:masterClrMapping/>
-  </p:clrMapOvr>
-</p:sld>
-</file>
-
-<file path=ppt/slides/slide12.xml><?xml version="1.0" encoding="utf-8"?>
-<p:sld xmlns:a="http://schemas.openxmlformats.org/drawingml/2006/main" xmlns:r="http://schemas.openxmlformats.org/officeDocument/2006/relationships" xmlns:p="http://schemas.openxmlformats.org/presentationml/2006/main">
-  <p:cSld>
-    <p:spTree>
-      <p:nvGrpSpPr>
-        <p:cNvPr id="1" name="">
-          <a:extLst>
-            <a:ext uri="{FF2B5EF4-FFF2-40B4-BE49-F238E27FC236}">
-              <a16:creationId xmlns:a16="http://schemas.microsoft.com/office/drawing/2014/main" id="{5E49A9FB-7BFC-25C7-AB3A-5D37EEE0DC13}"/>
-            </a:ext>
-          </a:extLst>
-        </p:cNvPr>
-        <p:cNvGrpSpPr/>
-        <p:nvPr/>
-      </p:nvGrpSpPr>
-      <p:grpSpPr>
-        <a:xfrm>
-          <a:off x="0" y="0"/>
-          <a:ext cx="0" cy="0"/>
-          <a:chOff x="0" y="0"/>
-          <a:chExt cx="0" cy="0"/>
-        </a:xfrm>
-      </p:grpSpPr>
-      <p:sp>
-        <p:nvSpPr>
-          <p:cNvPr id="2" name="Titel 1">
-            <a:extLst>
-              <a:ext uri="{FF2B5EF4-FFF2-40B4-BE49-F238E27FC236}">
-                <a16:creationId xmlns:a16="http://schemas.microsoft.com/office/drawing/2014/main" id="{44398118-C6A7-7E20-E430-1765C8A9FE90}"/>
-              </a:ext>
-            </a:extLst>
-          </p:cNvPr>
-          <p:cNvSpPr>
-            <a:spLocks noGrp="1"/>
-          </p:cNvSpPr>
-          <p:nvPr>
-            <p:ph type="title"/>
-          </p:nvPr>
-        </p:nvSpPr>
-        <p:spPr/>
-        <p:txBody>
-          <a:bodyPr/>
-          <a:lstStyle/>
-          <a:p>
-            <a:r>
-              <a:rPr lang="de-DE" dirty="0"/>
-              <a:t>Project 3: Group 4</a:t>
-            </a:r>
-          </a:p>
-        </p:txBody>
-      </p:sp>
-      <p:sp>
-        <p:nvSpPr>
-          <p:cNvPr id="3" name="Inhaltsplatzhalter 2">
-            <a:extLst>
-              <a:ext uri="{FF2B5EF4-FFF2-40B4-BE49-F238E27FC236}">
-                <a16:creationId xmlns:a16="http://schemas.microsoft.com/office/drawing/2014/main" id="{3D98888B-17B4-BEDA-57E2-04A8FF1C71FC}"/>
-              </a:ext>
-            </a:extLst>
-          </p:cNvPr>
-          <p:cNvSpPr>
-            <a:spLocks noGrp="1"/>
-          </p:cNvSpPr>
-          <p:nvPr>
-            <p:ph idx="1"/>
-          </p:nvPr>
-        </p:nvSpPr>
-        <p:spPr/>
-        <p:txBody>
-          <a:bodyPr>
-            <a:normAutofit/>
-          </a:bodyPr>
-          <a:lstStyle/>
-          <a:p>
-            <a:pPr marL="0" indent="0">
-              <a:buNone/>
-            </a:pPr>
-            <a:r>
-              <a:rPr lang="de-DE" sz="4200" dirty="0" err="1"/>
-              <a:t>Inpainting</a:t>
-            </a:r>
-            <a:r>
-              <a:rPr lang="de-DE" sz="4200" dirty="0"/>
-              <a:t> </a:t>
-            </a:r>
-            <a:r>
-              <a:rPr lang="de-DE" sz="4200" dirty="0" err="1"/>
-              <a:t>with</a:t>
-            </a:r>
-            <a:r>
-              <a:rPr lang="de-DE" sz="4200" dirty="0"/>
-              <a:t> AI</a:t>
-            </a:r>
-          </a:p>
-          <a:p>
-            <a:pPr marL="0" indent="0">
-              <a:buNone/>
-            </a:pPr>
-            <a:endParaRPr lang="de-DE" dirty="0"/>
-          </a:p>
-          <a:p>
-            <a:pPr marL="0" indent="0">
-              <a:buNone/>
-            </a:pPr>
-            <a:r>
-              <a:rPr lang="de-DE" dirty="0"/>
-              <a:t>Prompt an </a:t>
-            </a:r>
-            <a:r>
-              <a:rPr lang="de-DE" dirty="0" err="1"/>
-              <a:t>image</a:t>
-            </a:r>
-            <a:r>
-              <a:rPr lang="de-DE" dirty="0"/>
-              <a:t> </a:t>
-            </a:r>
-            <a:r>
-              <a:rPr lang="de-DE" dirty="0" err="1"/>
-              <a:t>synthesis</a:t>
-            </a:r>
-            <a:r>
-              <a:rPr lang="de-DE" dirty="0"/>
-              <a:t> </a:t>
-            </a:r>
-            <a:r>
-              <a:rPr lang="de-DE" dirty="0" err="1"/>
-              <a:t>model</a:t>
-            </a:r>
-            <a:r>
-              <a:rPr lang="de-DE" dirty="0"/>
-              <a:t> </a:t>
-            </a:r>
-            <a:r>
-              <a:rPr lang="de-DE" dirty="0" err="1"/>
-              <a:t>to</a:t>
-            </a:r>
-            <a:r>
-              <a:rPr lang="de-DE" dirty="0"/>
-              <a:t> </a:t>
-            </a:r>
-            <a:r>
-              <a:rPr lang="de-DE" dirty="0" err="1"/>
-              <a:t>generate</a:t>
-            </a:r>
-            <a:r>
-              <a:rPr lang="de-DE" dirty="0"/>
-              <a:t> a </a:t>
-            </a:r>
-            <a:r>
-              <a:rPr lang="de-DE" dirty="0" err="1"/>
-              <a:t>visualization</a:t>
-            </a:r>
-            <a:r>
-              <a:rPr lang="de-DE" dirty="0"/>
-              <a:t> </a:t>
-            </a:r>
-            <a:r>
-              <a:rPr lang="de-DE" dirty="0" err="1"/>
-              <a:t>of</a:t>
-            </a:r>
-            <a:r>
-              <a:rPr lang="de-DE" dirty="0"/>
-              <a:t> a possible design </a:t>
-            </a:r>
-            <a:r>
-              <a:rPr lang="de-DE" dirty="0" err="1"/>
-              <a:t>for</a:t>
-            </a:r>
-            <a:r>
-              <a:rPr lang="de-DE" dirty="0"/>
-              <a:t> </a:t>
-            </a:r>
-            <a:r>
-              <a:rPr lang="de-DE" dirty="0" err="1"/>
-              <a:t>my</a:t>
-            </a:r>
-            <a:r>
-              <a:rPr lang="de-DE" dirty="0"/>
-              <a:t> front </a:t>
-            </a:r>
-            <a:r>
-              <a:rPr lang="de-DE" dirty="0" err="1"/>
-              <a:t>garden</a:t>
-            </a:r>
-            <a:r>
-              <a:rPr lang="de-DE" dirty="0"/>
-              <a:t>, </a:t>
-            </a:r>
-            <a:r>
-              <a:rPr lang="de-DE" dirty="0" err="1"/>
-              <a:t>using</a:t>
-            </a:r>
-            <a:r>
-              <a:rPr lang="de-DE" dirty="0"/>
-              <a:t> a </a:t>
-            </a:r>
-            <a:r>
-              <a:rPr lang="de-DE" dirty="0" err="1"/>
-              <a:t>photo</a:t>
-            </a:r>
-            <a:r>
-              <a:rPr lang="de-DE" dirty="0"/>
-              <a:t> </a:t>
-            </a:r>
-            <a:r>
-              <a:rPr lang="de-DE" dirty="0" err="1"/>
-              <a:t>of</a:t>
-            </a:r>
-            <a:r>
-              <a:rPr lang="de-DE" dirty="0"/>
-              <a:t> </a:t>
-            </a:r>
-            <a:r>
-              <a:rPr lang="de-DE" dirty="0" err="1"/>
-              <a:t>the</a:t>
-            </a:r>
-            <a:r>
-              <a:rPr lang="de-DE" dirty="0"/>
-              <a:t> </a:t>
-            </a:r>
-            <a:r>
-              <a:rPr lang="de-DE" dirty="0" err="1"/>
-              <a:t>empty</a:t>
-            </a:r>
-            <a:r>
-              <a:rPr lang="de-DE" dirty="0"/>
-              <a:t> </a:t>
-            </a:r>
-            <a:r>
-              <a:rPr lang="de-DE" dirty="0" err="1"/>
-              <a:t>garden</a:t>
-            </a:r>
-            <a:r>
-              <a:rPr lang="de-DE" dirty="0"/>
-              <a:t> and a </a:t>
-            </a:r>
-            <a:r>
-              <a:rPr lang="de-DE" dirty="0" err="1"/>
-              <a:t>sketched</a:t>
-            </a:r>
-            <a:r>
-              <a:rPr lang="de-DE" dirty="0"/>
-              <a:t> </a:t>
-            </a:r>
-            <a:r>
-              <a:rPr lang="de-DE" dirty="0" err="1"/>
-              <a:t>planting</a:t>
-            </a:r>
-            <a:r>
-              <a:rPr lang="de-DE" dirty="0"/>
-              <a:t> plan.</a:t>
-            </a:r>
-          </a:p>
-          <a:p>
-            <a:pPr marL="0" indent="0">
-              <a:buNone/>
-            </a:pPr>
-            <a:endParaRPr lang="de-DE" dirty="0"/>
-          </a:p>
-          <a:p>
-            <a:pPr marL="0" indent="0">
-              <a:buNone/>
-            </a:pPr>
-            <a:r>
-              <a:rPr lang="de-DE" dirty="0"/>
-              <a:t>(</a:t>
-            </a:r>
-            <a:r>
-              <a:rPr lang="de-DE" dirty="0" err="1"/>
-              <a:t>You</a:t>
-            </a:r>
-            <a:r>
-              <a:rPr lang="de-DE" dirty="0"/>
-              <a:t> </a:t>
-            </a:r>
-            <a:r>
-              <a:rPr lang="de-DE" dirty="0" err="1"/>
-              <a:t>can</a:t>
-            </a:r>
-            <a:r>
-              <a:rPr lang="de-DE" dirty="0"/>
-              <a:t> find </a:t>
-            </a:r>
-            <a:r>
-              <a:rPr lang="de-DE" dirty="0" err="1"/>
-              <a:t>the</a:t>
-            </a:r>
-            <a:r>
-              <a:rPr lang="de-DE" dirty="0"/>
-              <a:t> </a:t>
-            </a:r>
-            <a:r>
-              <a:rPr lang="de-DE" dirty="0" err="1"/>
-              <a:t>two</a:t>
-            </a:r>
-            <a:r>
-              <a:rPr lang="de-DE" dirty="0"/>
-              <a:t> </a:t>
-            </a:r>
-            <a:r>
-              <a:rPr lang="de-DE" dirty="0" err="1"/>
-              <a:t>input</a:t>
-            </a:r>
-            <a:r>
-              <a:rPr lang="de-DE" dirty="0"/>
-              <a:t> </a:t>
-            </a:r>
-            <a:r>
-              <a:rPr lang="de-DE" dirty="0" err="1"/>
-              <a:t>images</a:t>
-            </a:r>
-            <a:r>
-              <a:rPr lang="de-DE" dirty="0"/>
-              <a:t> in </a:t>
-            </a:r>
-            <a:r>
-              <a:rPr lang="de-DE" dirty="0" err="1"/>
-              <a:t>the</a:t>
-            </a:r>
-            <a:r>
-              <a:rPr lang="de-DE" dirty="0"/>
-              <a:t> </a:t>
-            </a:r>
-            <a:r>
-              <a:rPr lang="de-DE" dirty="0" err="1"/>
-              <a:t>projects</a:t>
-            </a:r>
-            <a:r>
-              <a:rPr lang="de-DE" dirty="0"/>
-              <a:t> </a:t>
-            </a:r>
-            <a:r>
-              <a:rPr lang="de-DE" dirty="0" err="1"/>
-              <a:t>folder</a:t>
-            </a:r>
-            <a:r>
-              <a:rPr lang="de-DE" dirty="0"/>
-              <a:t> </a:t>
-            </a:r>
-            <a:r>
-              <a:rPr lang="de-DE" dirty="0" err="1"/>
-              <a:t>of</a:t>
-            </a:r>
-            <a:r>
-              <a:rPr lang="de-DE" dirty="0"/>
-              <a:t> </a:t>
-            </a:r>
-            <a:r>
-              <a:rPr lang="de-DE" dirty="0" err="1"/>
-              <a:t>the</a:t>
-            </a:r>
-            <a:r>
-              <a:rPr lang="de-DE" dirty="0"/>
-              <a:t> OLAT </a:t>
-            </a:r>
-            <a:r>
-              <a:rPr lang="de-DE" dirty="0" err="1"/>
-              <a:t>course</a:t>
-            </a:r>
-            <a:r>
-              <a:rPr lang="de-DE" dirty="0"/>
-              <a:t>.)</a:t>
-            </a:r>
-          </a:p>
-        </p:txBody>
-      </p:sp>
-    </p:spTree>
-    <p:extLst>
-      <p:ext uri="{BB962C8B-B14F-4D97-AF65-F5344CB8AC3E}">
-        <p14:creationId xmlns:p14="http://schemas.microsoft.com/office/powerpoint/2010/main" val="3845501386"/>
-      </p:ext>
-    </p:extLst>
-  </p:cSld>
-  <p:clrMapOvr>
-    <a:masterClrMapping/>
-  </p:clrMapOvr>
-</p:sld>
-</file>
-
-<file path=ppt/slides/slide2.xml><?xml version="1.0" encoding="utf-8"?>
-<p:sld xmlns:a="http://schemas.openxmlformats.org/drawingml/2006/main" xmlns:r="http://schemas.openxmlformats.org/officeDocument/2006/relationships" xmlns:p="http://schemas.openxmlformats.org/presentationml/2006/main">
-  <p:cSld>
-    <p:spTree>
-      <p:nvGrpSpPr>
-        <p:cNvPr id="1" name="">
-          <a:extLst>
-            <a:ext uri="{FF2B5EF4-FFF2-40B4-BE49-F238E27FC236}">
-              <a16:creationId xmlns:a16="http://schemas.microsoft.com/office/drawing/2014/main" id="{E6558583-B400-0DF2-C7D7-FC745A2DC4DD}"/>
-            </a:ext>
-          </a:extLst>
-        </p:cNvPr>
-        <p:cNvGrpSpPr/>
-        <p:nvPr/>
-      </p:nvGrpSpPr>
-      <p:grpSpPr>
-        <a:xfrm>
-          <a:off x="0" y="0"/>
-          <a:ext cx="0" cy="0"/>
-          <a:chOff x="0" y="0"/>
-          <a:chExt cx="0" cy="0"/>
-        </a:xfrm>
-      </p:grpSpPr>
-      <p:sp>
-        <p:nvSpPr>
-          <p:cNvPr id="2" name="Titel 1">
-            <a:extLst>
-              <a:ext uri="{FF2B5EF4-FFF2-40B4-BE49-F238E27FC236}">
-                <a16:creationId xmlns:a16="http://schemas.microsoft.com/office/drawing/2014/main" id="{0D480933-3B44-FBD2-1A67-3D9A01120F02}"/>
-              </a:ext>
-            </a:extLst>
-          </p:cNvPr>
-          <p:cNvSpPr>
-            <a:spLocks noGrp="1"/>
-          </p:cNvSpPr>
-          <p:nvPr>
-            <p:ph type="title"/>
-          </p:nvPr>
-        </p:nvSpPr>
-        <p:spPr/>
-        <p:txBody>
-          <a:bodyPr/>
-          <a:lstStyle/>
-          <a:p>
-            <a:r>
-              <a:rPr lang="de-DE" dirty="0"/>
-              <a:t>Project 1: Group 2</a:t>
-            </a:r>
-          </a:p>
-        </p:txBody>
-      </p:sp>
-      <p:sp>
-        <p:nvSpPr>
-          <p:cNvPr id="3" name="Inhaltsplatzhalter 2">
-            <a:extLst>
-              <a:ext uri="{FF2B5EF4-FFF2-40B4-BE49-F238E27FC236}">
-                <a16:creationId xmlns:a16="http://schemas.microsoft.com/office/drawing/2014/main" id="{AEE36AA6-7D67-E7CE-9784-B7B2BDB703F7}"/>
-              </a:ext>
-            </a:extLst>
-          </p:cNvPr>
-          <p:cNvSpPr>
-            <a:spLocks noGrp="1"/>
-          </p:cNvSpPr>
-          <p:nvPr>
-            <p:ph idx="1"/>
-          </p:nvPr>
-        </p:nvSpPr>
-        <p:spPr/>
-        <p:txBody>
-          <a:bodyPr/>
-          <a:lstStyle/>
-          <a:p>
-            <a:pPr marL="0" indent="0">
-              <a:buNone/>
-            </a:pPr>
-            <a:r>
-              <a:rPr lang="de-DE" sz="4200" dirty="0"/>
-              <a:t>Panorama </a:t>
-            </a:r>
-            <a:r>
-              <a:rPr lang="de-DE" sz="4200" dirty="0" err="1"/>
-              <a:t>Stitching</a:t>
-            </a:r>
-            <a:endParaRPr lang="de-DE" sz="4200" dirty="0"/>
-          </a:p>
-          <a:p>
-            <a:pPr marL="0" indent="0">
-              <a:buNone/>
-            </a:pPr>
-            <a:endParaRPr lang="de-DE" dirty="0"/>
-          </a:p>
-          <a:p>
-            <a:pPr marL="0" indent="0">
-              <a:buNone/>
-            </a:pPr>
-            <a:r>
-              <a:rPr lang="de-DE" dirty="0"/>
-              <a:t>Create a </a:t>
-            </a:r>
-            <a:r>
-              <a:rPr lang="de-DE" dirty="0" err="1"/>
-              <a:t>panorama</a:t>
-            </a:r>
-            <a:r>
-              <a:rPr lang="de-DE" dirty="0"/>
-              <a:t> </a:t>
-            </a:r>
-            <a:r>
-              <a:rPr lang="de-DE" dirty="0" err="1"/>
-              <a:t>image</a:t>
-            </a:r>
-            <a:r>
-              <a:rPr lang="de-DE" dirty="0"/>
-              <a:t> </a:t>
-            </a:r>
-            <a:r>
-              <a:rPr lang="de-DE" dirty="0" err="1"/>
-              <a:t>from</a:t>
-            </a:r>
-            <a:r>
-              <a:rPr lang="de-DE" dirty="0"/>
-              <a:t> </a:t>
-            </a:r>
-            <a:r>
-              <a:rPr lang="de-DE" dirty="0" err="1"/>
-              <a:t>two</a:t>
-            </a:r>
-            <a:r>
-              <a:rPr lang="de-DE" dirty="0"/>
-              <a:t> (</a:t>
-            </a:r>
-            <a:r>
-              <a:rPr lang="de-DE" dirty="0" err="1"/>
-              <a:t>or</a:t>
-            </a:r>
-            <a:r>
-              <a:rPr lang="de-DE" dirty="0"/>
-              <a:t> </a:t>
-            </a:r>
-            <a:r>
-              <a:rPr lang="de-DE" dirty="0" err="1"/>
-              <a:t>more</a:t>
-            </a:r>
-            <a:r>
-              <a:rPr lang="de-DE" dirty="0"/>
-              <a:t>) </a:t>
-            </a:r>
-            <a:r>
-              <a:rPr lang="de-DE" dirty="0" err="1"/>
-              <a:t>overlapping</a:t>
-            </a:r>
-            <a:r>
-              <a:rPr lang="de-DE" dirty="0"/>
-              <a:t> </a:t>
-            </a:r>
-            <a:r>
-              <a:rPr lang="de-DE" dirty="0" err="1"/>
-              <a:t>photos</a:t>
-            </a:r>
-            <a:r>
-              <a:rPr lang="de-DE" dirty="0"/>
-              <a:t>.</a:t>
-            </a:r>
-          </a:p>
-          <a:p>
-            <a:pPr marL="0" indent="0">
-              <a:buNone/>
-            </a:pPr>
-            <a:endParaRPr lang="de-DE" dirty="0"/>
-          </a:p>
-          <a:p>
-            <a:pPr marL="0" indent="0">
-              <a:buNone/>
-            </a:pPr>
-            <a:r>
-              <a:rPr lang="de-DE" dirty="0"/>
-              <a:t>(</a:t>
-            </a:r>
-            <a:r>
-              <a:rPr lang="de-DE" dirty="0" err="1"/>
-              <a:t>You</a:t>
-            </a:r>
-            <a:r>
-              <a:rPr lang="de-DE" dirty="0"/>
-              <a:t> </a:t>
-            </a:r>
-            <a:r>
-              <a:rPr lang="de-DE" dirty="0" err="1"/>
-              <a:t>can</a:t>
-            </a:r>
-            <a:r>
-              <a:rPr lang="de-DE" dirty="0"/>
-              <a:t> </a:t>
-            </a:r>
-            <a:r>
-              <a:rPr lang="de-DE" dirty="0" err="1"/>
-              <a:t>use</a:t>
-            </a:r>
-            <a:r>
-              <a:rPr lang="de-DE" dirty="0"/>
-              <a:t> </a:t>
-            </a:r>
-            <a:r>
-              <a:rPr lang="de-DE" dirty="0" err="1"/>
-              <a:t>any</a:t>
-            </a:r>
-            <a:r>
-              <a:rPr lang="de-DE" dirty="0"/>
-              <a:t> </a:t>
-            </a:r>
-            <a:r>
-              <a:rPr lang="de-DE" dirty="0" err="1"/>
-              <a:t>images</a:t>
-            </a:r>
-            <a:r>
-              <a:rPr lang="de-DE" dirty="0"/>
-              <a:t> </a:t>
-            </a:r>
-            <a:r>
-              <a:rPr lang="de-DE" dirty="0" err="1"/>
-              <a:t>you</a:t>
-            </a:r>
-            <a:r>
-              <a:rPr lang="de-DE" dirty="0"/>
-              <a:t> like </a:t>
-            </a:r>
-            <a:r>
-              <a:rPr lang="de-DE" dirty="0" err="1"/>
-              <a:t>for</a:t>
-            </a:r>
-            <a:r>
-              <a:rPr lang="de-DE" dirty="0"/>
-              <a:t> </a:t>
-            </a:r>
-            <a:r>
-              <a:rPr lang="de-DE" dirty="0" err="1"/>
-              <a:t>this</a:t>
-            </a:r>
-            <a:r>
-              <a:rPr lang="de-DE" dirty="0"/>
-              <a:t>.)</a:t>
-            </a:r>
-          </a:p>
-        </p:txBody>
-      </p:sp>
-    </p:spTree>
-    <p:extLst>
-      <p:ext uri="{BB962C8B-B14F-4D97-AF65-F5344CB8AC3E}">
-        <p14:creationId xmlns:p14="http://schemas.microsoft.com/office/powerpoint/2010/main" val="1321817972"/>
-      </p:ext>
-    </p:extLst>
-  </p:cSld>
-  <p:clrMapOvr>
-    <a:masterClrMapping/>
-  </p:clrMapOvr>
-</p:sld>
-</file>
-
-<file path=ppt/slides/slide3.xml><?xml version="1.0" encoding="utf-8"?>
-<p:sld xmlns:a="http://schemas.openxmlformats.org/drawingml/2006/main" xmlns:r="http://schemas.openxmlformats.org/officeDocument/2006/relationships" xmlns:p="http://schemas.openxmlformats.org/presentationml/2006/main">
-  <p:cSld>
-    <p:spTree>
-      <p:nvGrpSpPr>
-        <p:cNvPr id="1" name="">
-          <a:extLst>
-            <a:ext uri="{FF2B5EF4-FFF2-40B4-BE49-F238E27FC236}">
-              <a16:creationId xmlns:a16="http://schemas.microsoft.com/office/drawing/2014/main" id="{7798A83E-10A3-E071-C3F3-798036F8EE2C}"/>
-            </a:ext>
-          </a:extLst>
-        </p:cNvPr>
-        <p:cNvGrpSpPr/>
-        <p:nvPr/>
-      </p:nvGrpSpPr>
-      <p:grpSpPr>
-        <a:xfrm>
-          <a:off x="0" y="0"/>
-          <a:ext cx="0" cy="0"/>
-          <a:chOff x="0" y="0"/>
-          <a:chExt cx="0" cy="0"/>
-        </a:xfrm>
-      </p:grpSpPr>
-      <p:sp>
-        <p:nvSpPr>
-          <p:cNvPr id="2" name="Titel 1">
-            <a:extLst>
-              <a:ext uri="{FF2B5EF4-FFF2-40B4-BE49-F238E27FC236}">
-                <a16:creationId xmlns:a16="http://schemas.microsoft.com/office/drawing/2014/main" id="{C3525E24-260F-0322-3E0F-55165212AC56}"/>
-              </a:ext>
-            </a:extLst>
-          </p:cNvPr>
-          <p:cNvSpPr>
-            <a:spLocks noGrp="1"/>
-          </p:cNvSpPr>
-          <p:nvPr>
-            <p:ph type="title"/>
-          </p:nvPr>
-        </p:nvSpPr>
-        <p:spPr/>
-        <p:txBody>
-          <a:bodyPr/>
-          <a:lstStyle/>
-          <a:p>
-            <a:r>
-              <a:rPr lang="de-DE" dirty="0"/>
-              <a:t>Project 1: Group 3</a:t>
-            </a:r>
-          </a:p>
-        </p:txBody>
-      </p:sp>
-      <p:sp>
-        <p:nvSpPr>
-          <p:cNvPr id="3" name="Inhaltsplatzhalter 2">
-            <a:extLst>
-              <a:ext uri="{FF2B5EF4-FFF2-40B4-BE49-F238E27FC236}">
-                <a16:creationId xmlns:a16="http://schemas.microsoft.com/office/drawing/2014/main" id="{716D2659-A329-EACE-8455-5261BBF8694C}"/>
-              </a:ext>
-            </a:extLst>
-          </p:cNvPr>
-          <p:cNvSpPr>
-            <a:spLocks noGrp="1"/>
-          </p:cNvSpPr>
-          <p:nvPr>
-            <p:ph idx="1"/>
-          </p:nvPr>
-        </p:nvSpPr>
-        <p:spPr/>
-        <p:txBody>
-          <a:bodyPr/>
-          <a:lstStyle/>
-          <a:p>
-            <a:pPr marL="0" indent="0">
-              <a:buNone/>
-            </a:pPr>
-            <a:r>
-              <a:rPr lang="de-DE" sz="4200" dirty="0"/>
-              <a:t>Feature-</a:t>
-            </a:r>
-            <a:r>
-              <a:rPr lang="de-DE" sz="4200" dirty="0" err="1"/>
-              <a:t>based</a:t>
-            </a:r>
-            <a:r>
-              <a:rPr lang="de-DE" sz="4200" dirty="0"/>
-              <a:t> Image Forensics</a:t>
-            </a:r>
-          </a:p>
-          <a:p>
-            <a:pPr marL="0" indent="0">
-              <a:buNone/>
-            </a:pPr>
-            <a:endParaRPr lang="de-DE" dirty="0"/>
-          </a:p>
-          <a:p>
-            <a:pPr marL="0" indent="0">
-              <a:buNone/>
-            </a:pPr>
-            <a:r>
-              <a:rPr lang="de-DE" dirty="0" err="1"/>
-              <a:t>Locate</a:t>
-            </a:r>
-            <a:r>
-              <a:rPr lang="de-DE" dirty="0"/>
-              <a:t> </a:t>
-            </a:r>
-            <a:r>
-              <a:rPr lang="de-DE" dirty="0" err="1"/>
-              <a:t>altered</a:t>
-            </a:r>
-            <a:r>
-              <a:rPr lang="de-DE" dirty="0"/>
-              <a:t> </a:t>
-            </a:r>
-            <a:r>
-              <a:rPr lang="de-DE" dirty="0" err="1"/>
-              <a:t>regions</a:t>
-            </a:r>
-            <a:r>
-              <a:rPr lang="de-DE" dirty="0"/>
-              <a:t> in </a:t>
-            </a:r>
-            <a:r>
-              <a:rPr lang="de-DE" dirty="0" err="1"/>
-              <a:t>some</a:t>
-            </a:r>
-            <a:r>
-              <a:rPr lang="de-DE" dirty="0"/>
-              <a:t> </a:t>
-            </a:r>
-            <a:r>
-              <a:rPr lang="de-DE" dirty="0" err="1"/>
-              <a:t>copy-move-manipulated</a:t>
-            </a:r>
-            <a:r>
-              <a:rPr lang="de-DE" dirty="0"/>
-              <a:t> </a:t>
-            </a:r>
-            <a:r>
-              <a:rPr lang="de-DE" dirty="0" err="1"/>
-              <a:t>images</a:t>
-            </a:r>
-            <a:r>
-              <a:rPr lang="de-DE" dirty="0"/>
-              <a:t>.</a:t>
-            </a:r>
-          </a:p>
-          <a:p>
-            <a:pPr marL="0" indent="0">
-              <a:buNone/>
-            </a:pPr>
-            <a:endParaRPr lang="de-DE" dirty="0"/>
-          </a:p>
-          <a:p>
-            <a:pPr marL="0" indent="0">
-              <a:buNone/>
-            </a:pPr>
-            <a:r>
-              <a:rPr lang="de-DE" dirty="0"/>
-              <a:t>(</a:t>
-            </a:r>
-            <a:r>
-              <a:rPr lang="de-DE" dirty="0" err="1"/>
-              <a:t>You</a:t>
-            </a:r>
-            <a:r>
-              <a:rPr lang="de-DE" dirty="0"/>
-              <a:t> </a:t>
-            </a:r>
-            <a:r>
-              <a:rPr lang="de-DE" dirty="0" err="1"/>
-              <a:t>can</a:t>
-            </a:r>
-            <a:r>
-              <a:rPr lang="de-DE" dirty="0"/>
-              <a:t> </a:t>
-            </a:r>
-            <a:r>
-              <a:rPr lang="de-DE" dirty="0" err="1"/>
-              <a:t>use</a:t>
-            </a:r>
-            <a:r>
-              <a:rPr lang="de-DE" dirty="0"/>
-              <a:t> </a:t>
-            </a:r>
-            <a:r>
-              <a:rPr lang="de-DE" dirty="0" err="1"/>
-              <a:t>images</a:t>
-            </a:r>
-            <a:r>
-              <a:rPr lang="de-DE" dirty="0"/>
-              <a:t> </a:t>
-            </a:r>
-            <a:r>
-              <a:rPr lang="de-DE" dirty="0" err="1"/>
-              <a:t>from</a:t>
-            </a:r>
-            <a:r>
-              <a:rPr lang="de-DE" dirty="0"/>
-              <a:t> </a:t>
-            </a:r>
-            <a:r>
-              <a:rPr lang="de-DE" dirty="0">
-                <a:hlinkClick r:id="rId2"/>
-              </a:rPr>
-              <a:t>Image Manipulation Dataset</a:t>
-            </a:r>
-            <a:r>
-              <a:rPr lang="de-DE" dirty="0"/>
-              <a:t>. But </a:t>
-            </a:r>
-            <a:r>
-              <a:rPr lang="de-DE" dirty="0" err="1"/>
-              <a:t>other</a:t>
-            </a:r>
-            <a:r>
-              <a:rPr lang="de-DE" dirty="0"/>
-              <a:t> </a:t>
-            </a:r>
-            <a:r>
-              <a:rPr lang="de-DE" dirty="0" err="1"/>
-              <a:t>images</a:t>
-            </a:r>
-            <a:r>
-              <a:rPr lang="de-DE" dirty="0"/>
-              <a:t> </a:t>
-            </a:r>
-            <a:r>
-              <a:rPr lang="de-DE" dirty="0" err="1"/>
-              <a:t>are</a:t>
-            </a:r>
-            <a:r>
-              <a:rPr lang="de-DE" dirty="0"/>
-              <a:t> also </a:t>
-            </a:r>
-            <a:r>
-              <a:rPr lang="de-DE" dirty="0" err="1"/>
-              <a:t>fine</a:t>
-            </a:r>
-            <a:r>
-              <a:rPr lang="de-DE" dirty="0"/>
-              <a:t>.)</a:t>
-            </a:r>
-          </a:p>
-        </p:txBody>
-      </p:sp>
-    </p:spTree>
-    <p:extLst>
-      <p:ext uri="{BB962C8B-B14F-4D97-AF65-F5344CB8AC3E}">
-        <p14:creationId xmlns:p14="http://schemas.microsoft.com/office/powerpoint/2010/main" val="1179495467"/>
-      </p:ext>
-    </p:extLst>
-  </p:cSld>
-  <p:clrMapOvr>
-    <a:masterClrMapping/>
-  </p:clrMapOvr>
-</p:sld>
-</file>
-
-<file path=ppt/slides/slide4.xml><?xml version="1.0" encoding="utf-8"?>
-<p:sld xmlns:a="http://schemas.openxmlformats.org/drawingml/2006/main" xmlns:r="http://schemas.openxmlformats.org/officeDocument/2006/relationships" xmlns:p="http://schemas.openxmlformats.org/presentationml/2006/main">
-  <p:cSld>
-    <p:spTree>
-      <p:nvGrpSpPr>
-        <p:cNvPr id="1" name=""/>
-        <p:cNvGrpSpPr/>
-        <p:nvPr/>
-      </p:nvGrpSpPr>
-      <p:grpSpPr>
-        <a:xfrm>
-          <a:off x="0" y="0"/>
-          <a:ext cx="0" cy="0"/>
-          <a:chOff x="0" y="0"/>
-          <a:chExt cx="0" cy="0"/>
-        </a:xfrm>
-      </p:grpSpPr>
-      <p:sp>
-        <p:nvSpPr>
-          <p:cNvPr id="2" name="Titel 1">
-            <a:extLst>
-              <a:ext uri="{FF2B5EF4-FFF2-40B4-BE49-F238E27FC236}">
-                <a16:creationId xmlns:a16="http://schemas.microsoft.com/office/drawing/2014/main" id="{B36A56C2-F2B3-C368-7E17-D99DEC298454}"/>
-              </a:ext>
-            </a:extLst>
-          </p:cNvPr>
-          <p:cNvSpPr>
-            <a:spLocks noGrp="1"/>
-          </p:cNvSpPr>
-          <p:nvPr>
-            <p:ph type="title"/>
-          </p:nvPr>
-        </p:nvSpPr>
-        <p:spPr/>
-        <p:txBody>
-          <a:bodyPr/>
-          <a:lstStyle/>
-          <a:p>
-            <a:r>
-              <a:rPr lang="de-DE" dirty="0"/>
-              <a:t>Project 1: Group 4</a:t>
-            </a:r>
-          </a:p>
-        </p:txBody>
-      </p:sp>
-      <p:sp>
-        <p:nvSpPr>
-          <p:cNvPr id="3" name="Inhaltsplatzhalter 2">
-            <a:extLst>
-              <a:ext uri="{FF2B5EF4-FFF2-40B4-BE49-F238E27FC236}">
-                <a16:creationId xmlns:a16="http://schemas.microsoft.com/office/drawing/2014/main" id="{9274D432-B0FA-CB2B-BFE2-F35E81B74008}"/>
-              </a:ext>
-            </a:extLst>
-          </p:cNvPr>
-          <p:cNvSpPr>
-            <a:spLocks noGrp="1"/>
-          </p:cNvSpPr>
-          <p:nvPr>
-            <p:ph idx="1"/>
-          </p:nvPr>
-        </p:nvSpPr>
-        <p:spPr/>
-        <p:txBody>
-          <a:bodyPr>
-            <a:normAutofit/>
-          </a:bodyPr>
-          <a:lstStyle/>
-          <a:p>
-            <a:pPr marL="0" indent="0" algn="ctr">
-              <a:buNone/>
-            </a:pPr>
-            <a:endParaRPr lang="de-DE" sz="5000" dirty="0"/>
-          </a:p>
-          <a:p>
-            <a:pPr marL="0" indent="0" algn="ctr">
-              <a:buNone/>
-            </a:pPr>
-            <a:r>
-              <a:rPr lang="de-DE" sz="5000" dirty="0" err="1"/>
-              <a:t>Kaggle</a:t>
-            </a:r>
-            <a:r>
-              <a:rPr lang="de-DE" sz="5000" dirty="0"/>
-              <a:t>:</a:t>
-            </a:r>
-          </a:p>
-          <a:p>
-            <a:pPr marL="0" indent="0" algn="ctr">
-              <a:buNone/>
-            </a:pPr>
-            <a:r>
-              <a:rPr lang="de-DE" sz="5000" dirty="0">
-                <a:hlinkClick r:id="rId2"/>
-              </a:rPr>
-              <a:t>Leaf Classification</a:t>
-            </a:r>
-            <a:endParaRPr lang="de-DE" sz="5000" dirty="0"/>
-          </a:p>
-        </p:txBody>
-      </p:sp>
-    </p:spTree>
-    <p:extLst>
-      <p:ext uri="{BB962C8B-B14F-4D97-AF65-F5344CB8AC3E}">
-        <p14:creationId xmlns:p14="http://schemas.microsoft.com/office/powerpoint/2010/main" val="3021455303"/>
-      </p:ext>
-    </p:extLst>
-  </p:cSld>
-  <p:clrMapOvr>
-    <a:masterClrMapping/>
-  </p:clrMapOvr>
-</p:sld>
-</file>
-
-<file path=ppt/slides/slide5.xml><?xml version="1.0" encoding="utf-8"?>
-<p:sld xmlns:a="http://schemas.openxmlformats.org/drawingml/2006/main" xmlns:r="http://schemas.openxmlformats.org/officeDocument/2006/relationships" xmlns:p="http://schemas.openxmlformats.org/presentationml/2006/main">
-  <p:cSld>
-    <p:spTree>
-      <p:nvGrpSpPr>
-        <p:cNvPr id="1" name="">
-          <a:extLst>
-            <a:ext uri="{FF2B5EF4-FFF2-40B4-BE49-F238E27FC236}">
-              <a16:creationId xmlns:a16="http://schemas.microsoft.com/office/drawing/2014/main" id="{FA00803C-B780-09A2-08E0-C620A6CE51C5}"/>
-            </a:ext>
-          </a:extLst>
-        </p:cNvPr>
-        <p:cNvGrpSpPr/>
-        <p:nvPr/>
-      </p:nvGrpSpPr>
-      <p:grpSpPr>
-        <a:xfrm>
-          <a:off x="0" y="0"/>
-          <a:ext cx="0" cy="0"/>
-          <a:chOff x="0" y="0"/>
-          <a:chExt cx="0" cy="0"/>
-        </a:xfrm>
-      </p:grpSpPr>
-      <p:sp>
-        <p:nvSpPr>
-          <p:cNvPr id="2" name="Titel 1">
-            <a:extLst>
-              <a:ext uri="{FF2B5EF4-FFF2-40B4-BE49-F238E27FC236}">
-                <a16:creationId xmlns:a16="http://schemas.microsoft.com/office/drawing/2014/main" id="{7D5AF378-539B-2EBF-A2F0-B5EA4302E5FC}"/>
-              </a:ext>
-            </a:extLst>
-          </p:cNvPr>
-          <p:cNvSpPr>
-            <a:spLocks noGrp="1"/>
-          </p:cNvSpPr>
-          <p:nvPr>
-            <p:ph type="title"/>
-          </p:nvPr>
-        </p:nvSpPr>
-        <p:spPr/>
-        <p:txBody>
-          <a:bodyPr/>
-          <a:lstStyle/>
-          <a:p>
-            <a:r>
-              <a:rPr lang="de-DE" dirty="0"/>
-              <a:t>Project 2: Group 1</a:t>
-            </a:r>
-          </a:p>
-        </p:txBody>
-      </p:sp>
-      <p:sp>
-        <p:nvSpPr>
-          <p:cNvPr id="3" name="Inhaltsplatzhalter 2">
-            <a:extLst>
-              <a:ext uri="{FF2B5EF4-FFF2-40B4-BE49-F238E27FC236}">
-                <a16:creationId xmlns:a16="http://schemas.microsoft.com/office/drawing/2014/main" id="{DF4ABE68-D640-0211-011F-A8D9D242A2D7}"/>
-              </a:ext>
-            </a:extLst>
-          </p:cNvPr>
-          <p:cNvSpPr>
-            <a:spLocks noGrp="1"/>
-          </p:cNvSpPr>
-          <p:nvPr>
-            <p:ph idx="1"/>
-          </p:nvPr>
-        </p:nvSpPr>
-        <p:spPr/>
-        <p:txBody>
-          <a:bodyPr>
-            <a:normAutofit/>
-          </a:bodyPr>
-          <a:lstStyle/>
-          <a:p>
-            <a:pPr marL="0" indent="0" algn="ctr">
-              <a:buNone/>
-            </a:pPr>
-            <a:endParaRPr lang="de-DE" sz="5000" dirty="0"/>
-          </a:p>
-          <a:p>
-            <a:pPr marL="0" indent="0" algn="ctr">
-              <a:buNone/>
-            </a:pPr>
-            <a:r>
-              <a:rPr lang="de-DE" sz="5000" dirty="0" err="1"/>
-              <a:t>Kaggle</a:t>
-            </a:r>
-            <a:r>
-              <a:rPr lang="de-DE" sz="5000" dirty="0"/>
-              <a:t>:</a:t>
-            </a:r>
-          </a:p>
-          <a:p>
-            <a:pPr marL="0" indent="0" algn="ctr">
-              <a:buNone/>
-            </a:pPr>
-            <a:r>
-              <a:rPr lang="de-DE" sz="5000" dirty="0">
-                <a:hlinkClick r:id="rId2"/>
-              </a:rPr>
-              <a:t>Face Identification</a:t>
-            </a:r>
-            <a:endParaRPr lang="de-DE" sz="5000" dirty="0"/>
-          </a:p>
-        </p:txBody>
-      </p:sp>
-    </p:spTree>
-    <p:extLst>
-      <p:ext uri="{BB962C8B-B14F-4D97-AF65-F5344CB8AC3E}">
-        <p14:creationId xmlns:p14="http://schemas.microsoft.com/office/powerpoint/2010/main" val="677040233"/>
-      </p:ext>
-    </p:extLst>
-  </p:cSld>
-  <p:clrMapOvr>
-    <a:masterClrMapping/>
-  </p:clrMapOvr>
-</p:sld>
-</file>
-
-<file path=ppt/slides/slide6.xml><?xml version="1.0" encoding="utf-8"?>
-<p:sld xmlns:a="http://schemas.openxmlformats.org/drawingml/2006/main" xmlns:r="http://schemas.openxmlformats.org/officeDocument/2006/relationships" xmlns:p="http://schemas.openxmlformats.org/presentationml/2006/main">
-  <p:cSld>
-    <p:spTree>
-      <p:nvGrpSpPr>
-        <p:cNvPr id="1" name="">
-          <a:extLst>
-            <a:ext uri="{FF2B5EF4-FFF2-40B4-BE49-F238E27FC236}">
-              <a16:creationId xmlns:a16="http://schemas.microsoft.com/office/drawing/2014/main" id="{5B337196-24F8-E28E-33B0-A516B3DF34AC}"/>
-            </a:ext>
-          </a:extLst>
-        </p:cNvPr>
-        <p:cNvGrpSpPr/>
-        <p:nvPr/>
-      </p:nvGrpSpPr>
-      <p:grpSpPr>
-        <a:xfrm>
-          <a:off x="0" y="0"/>
-          <a:ext cx="0" cy="0"/>
-          <a:chOff x="0" y="0"/>
-          <a:chExt cx="0" cy="0"/>
-        </a:xfrm>
-      </p:grpSpPr>
-      <p:sp>
-        <p:nvSpPr>
-          <p:cNvPr id="2" name="Titel 1">
-            <a:extLst>
-              <a:ext uri="{FF2B5EF4-FFF2-40B4-BE49-F238E27FC236}">
-                <a16:creationId xmlns:a16="http://schemas.microsoft.com/office/drawing/2014/main" id="{59EBF755-03A6-10C2-DD84-2085E46348E7}"/>
-              </a:ext>
-            </a:extLst>
-          </p:cNvPr>
-          <p:cNvSpPr>
-            <a:spLocks noGrp="1"/>
-          </p:cNvSpPr>
-          <p:nvPr>
-            <p:ph type="title"/>
-          </p:nvPr>
-        </p:nvSpPr>
-        <p:spPr/>
-        <p:txBody>
-          <a:bodyPr/>
-          <a:lstStyle/>
-          <a:p>
-            <a:r>
-              <a:rPr lang="de-DE" dirty="0"/>
-              <a:t>Project 2: Group 2</a:t>
-            </a:r>
-          </a:p>
-        </p:txBody>
-      </p:sp>
-      <p:sp>
-        <p:nvSpPr>
-          <p:cNvPr id="3" name="Inhaltsplatzhalter 2">
-            <a:extLst>
-              <a:ext uri="{FF2B5EF4-FFF2-40B4-BE49-F238E27FC236}">
-                <a16:creationId xmlns:a16="http://schemas.microsoft.com/office/drawing/2014/main" id="{228CA356-43A5-C784-3BD1-A9EB611B7301}"/>
-              </a:ext>
-            </a:extLst>
-          </p:cNvPr>
-          <p:cNvSpPr>
-            <a:spLocks noGrp="1"/>
-          </p:cNvSpPr>
-          <p:nvPr>
-            <p:ph idx="1"/>
-          </p:nvPr>
-        </p:nvSpPr>
-        <p:spPr/>
-        <p:txBody>
-          <a:bodyPr>
-            <a:normAutofit/>
-          </a:bodyPr>
-          <a:lstStyle/>
-          <a:p>
-            <a:pPr marL="0" indent="0" algn="ctr">
-              <a:buNone/>
-            </a:pPr>
-            <a:endParaRPr lang="de-DE" sz="5000" dirty="0"/>
-          </a:p>
-          <a:p>
-            <a:pPr marL="0" indent="0" algn="ctr">
-              <a:buNone/>
-            </a:pPr>
-            <a:r>
-              <a:rPr lang="de-DE" sz="5000" dirty="0" err="1"/>
-              <a:t>Kaggle</a:t>
-            </a:r>
-            <a:r>
-              <a:rPr lang="de-DE" sz="5000" dirty="0"/>
-              <a:t>:</a:t>
-            </a:r>
-          </a:p>
-          <a:p>
-            <a:pPr marL="0" indent="0" algn="ctr">
-              <a:buNone/>
-            </a:pPr>
-            <a:r>
-              <a:rPr lang="de-DE" sz="5000" dirty="0">
-                <a:hlinkClick r:id="rId2"/>
-              </a:rPr>
-              <a:t>Real or Generated</a:t>
-            </a:r>
-            <a:endParaRPr lang="de-DE" sz="5000" dirty="0"/>
-          </a:p>
-        </p:txBody>
-      </p:sp>
-    </p:spTree>
-    <p:extLst>
-      <p:ext uri="{BB962C8B-B14F-4D97-AF65-F5344CB8AC3E}">
-        <p14:creationId xmlns:p14="http://schemas.microsoft.com/office/powerpoint/2010/main" val="2810437318"/>
-      </p:ext>
-    </p:extLst>
-  </p:cSld>
-  <p:clrMapOvr>
-    <a:masterClrMapping/>
-  </p:clrMapOvr>
-</p:sld>
-</file>
-
-<file path=ppt/slides/slide7.xml><?xml version="1.0" encoding="utf-8"?>
-<p:sld xmlns:a="http://schemas.openxmlformats.org/drawingml/2006/main" xmlns:r="http://schemas.openxmlformats.org/officeDocument/2006/relationships" xmlns:p="http://schemas.openxmlformats.org/presentationml/2006/main">
-  <p:cSld>
-    <p:spTree>
-      <p:nvGrpSpPr>
-        <p:cNvPr id="1" name="">
-          <a:extLst>
-            <a:ext uri="{FF2B5EF4-FFF2-40B4-BE49-F238E27FC236}">
-              <a16:creationId xmlns:a16="http://schemas.microsoft.com/office/drawing/2014/main" id="{6C485F38-D6CA-7064-932E-92C69AC30093}"/>
-            </a:ext>
-          </a:extLst>
-        </p:cNvPr>
-        <p:cNvGrpSpPr/>
-        <p:nvPr/>
-      </p:nvGrpSpPr>
-      <p:grpSpPr>
-        <a:xfrm>
-          <a:off x="0" y="0"/>
-          <a:ext cx="0" cy="0"/>
-          <a:chOff x="0" y="0"/>
-          <a:chExt cx="0" cy="0"/>
-        </a:xfrm>
-      </p:grpSpPr>
-      <p:sp>
-        <p:nvSpPr>
-          <p:cNvPr id="2" name="Titel 1">
-            <a:extLst>
-              <a:ext uri="{FF2B5EF4-FFF2-40B4-BE49-F238E27FC236}">
-                <a16:creationId xmlns:a16="http://schemas.microsoft.com/office/drawing/2014/main" id="{263379EF-5084-E6DF-7ED0-47C4EA6AA718}"/>
-              </a:ext>
-            </a:extLst>
-          </p:cNvPr>
-          <p:cNvSpPr>
-            <a:spLocks noGrp="1"/>
-          </p:cNvSpPr>
-          <p:nvPr>
-            <p:ph type="title"/>
-          </p:nvPr>
-        </p:nvSpPr>
-        <p:spPr/>
-        <p:txBody>
-          <a:bodyPr/>
-          <a:lstStyle/>
-          <a:p>
-            <a:r>
-              <a:rPr lang="de-DE" dirty="0"/>
-              <a:t>Project 2: Group 3</a:t>
-            </a:r>
-          </a:p>
-        </p:txBody>
-      </p:sp>
-      <p:sp>
-        <p:nvSpPr>
-          <p:cNvPr id="3" name="Inhaltsplatzhalter 2">
-            <a:extLst>
-              <a:ext uri="{FF2B5EF4-FFF2-40B4-BE49-F238E27FC236}">
-                <a16:creationId xmlns:a16="http://schemas.microsoft.com/office/drawing/2014/main" id="{95499B61-62B2-2CEA-3C91-84A8B1A45AA2}"/>
-              </a:ext>
-            </a:extLst>
-          </p:cNvPr>
-          <p:cNvSpPr>
-            <a:spLocks noGrp="1"/>
-          </p:cNvSpPr>
-          <p:nvPr>
-            <p:ph idx="1"/>
-          </p:nvPr>
-        </p:nvSpPr>
-        <p:spPr/>
-        <p:txBody>
-          <a:bodyPr>
-            <a:normAutofit/>
-          </a:bodyPr>
-          <a:lstStyle/>
-          <a:p>
-            <a:pPr marL="0" indent="0" algn="ctr">
-              <a:buNone/>
-            </a:pPr>
-            <a:endParaRPr lang="de-DE" sz="5000" dirty="0"/>
-          </a:p>
-          <a:p>
-            <a:pPr marL="0" indent="0" algn="ctr">
-              <a:buNone/>
-            </a:pPr>
-            <a:r>
-              <a:rPr lang="de-DE" sz="5000" dirty="0" err="1"/>
-              <a:t>Kaggle</a:t>
-            </a:r>
-            <a:r>
-              <a:rPr lang="de-DE" sz="5000" dirty="0"/>
-              <a:t>:</a:t>
-            </a:r>
-          </a:p>
-          <a:p>
-            <a:pPr marL="0" indent="0" algn="ctr">
-              <a:buNone/>
-            </a:pPr>
-            <a:r>
-              <a:rPr lang="de-DE" sz="5000" dirty="0">
-                <a:hlinkClick r:id="rId2"/>
-              </a:rPr>
-              <a:t>Dogs vs. Cats</a:t>
-            </a:r>
-            <a:endParaRPr lang="de-DE" sz="5000" dirty="0"/>
-          </a:p>
-        </p:txBody>
-      </p:sp>
-    </p:spTree>
-    <p:extLst>
-      <p:ext uri="{BB962C8B-B14F-4D97-AF65-F5344CB8AC3E}">
-        <p14:creationId xmlns:p14="http://schemas.microsoft.com/office/powerpoint/2010/main" val="3663950801"/>
-      </p:ext>
-    </p:extLst>
-  </p:cSld>
-  <p:clrMapOvr>
-    <a:masterClrMapping/>
-  </p:clrMapOvr>
-</p:sld>
-</file>
-
-<file path=ppt/slides/slide8.xml><?xml version="1.0" encoding="utf-8"?>
-<p:sld xmlns:a="http://schemas.openxmlformats.org/drawingml/2006/main" xmlns:r="http://schemas.openxmlformats.org/officeDocument/2006/relationships" xmlns:p="http://schemas.openxmlformats.org/presentationml/2006/main">
-  <p:cSld>
-    <p:spTree>
-      <p:nvGrpSpPr>
-        <p:cNvPr id="1" name="">
-          <a:extLst>
-            <a:ext uri="{FF2B5EF4-FFF2-40B4-BE49-F238E27FC236}">
-              <a16:creationId xmlns:a16="http://schemas.microsoft.com/office/drawing/2014/main" id="{3A33991C-82A0-B914-7306-4B060B407632}"/>
-            </a:ext>
-          </a:extLst>
-        </p:cNvPr>
-        <p:cNvGrpSpPr/>
-        <p:nvPr/>
-      </p:nvGrpSpPr>
-      <p:grpSpPr>
-        <a:xfrm>
-          <a:off x="0" y="0"/>
-          <a:ext cx="0" cy="0"/>
-          <a:chOff x="0" y="0"/>
-          <a:chExt cx="0" cy="0"/>
-        </a:xfrm>
-      </p:grpSpPr>
-      <p:sp>
-        <p:nvSpPr>
-          <p:cNvPr id="2" name="Titel 1">
-            <a:extLst>
-              <a:ext uri="{FF2B5EF4-FFF2-40B4-BE49-F238E27FC236}">
-                <a16:creationId xmlns:a16="http://schemas.microsoft.com/office/drawing/2014/main" id="{2CDD0C51-416C-C5EE-4E3F-2E7ACC6F82CC}"/>
-              </a:ext>
-            </a:extLst>
-          </p:cNvPr>
-          <p:cNvSpPr>
-            <a:spLocks noGrp="1"/>
-          </p:cNvSpPr>
-          <p:nvPr>
-            <p:ph type="title"/>
-          </p:nvPr>
-        </p:nvSpPr>
-        <p:spPr/>
-        <p:txBody>
-          <a:bodyPr/>
-          <a:lstStyle/>
-          <a:p>
-            <a:r>
-              <a:rPr lang="de-DE" dirty="0"/>
-              <a:t>Project 2: Group 4</a:t>
-            </a:r>
-          </a:p>
-        </p:txBody>
-      </p:sp>
-      <p:sp>
-        <p:nvSpPr>
-          <p:cNvPr id="3" name="Inhaltsplatzhalter 2">
-            <a:extLst>
-              <a:ext uri="{FF2B5EF4-FFF2-40B4-BE49-F238E27FC236}">
-                <a16:creationId xmlns:a16="http://schemas.microsoft.com/office/drawing/2014/main" id="{BB0B091C-321A-EEED-80F5-511C8FF3BD04}"/>
-              </a:ext>
-            </a:extLst>
-          </p:cNvPr>
-          <p:cNvSpPr>
-            <a:spLocks noGrp="1"/>
-          </p:cNvSpPr>
-          <p:nvPr>
-            <p:ph idx="1"/>
-          </p:nvPr>
-        </p:nvSpPr>
-        <p:spPr/>
-        <p:txBody>
-          <a:bodyPr>
-            <a:normAutofit/>
-          </a:bodyPr>
-          <a:lstStyle/>
-          <a:p>
-            <a:pPr marL="0" indent="0" algn="ctr">
-              <a:buNone/>
-            </a:pPr>
-            <a:endParaRPr lang="de-DE" sz="5000" dirty="0"/>
-          </a:p>
-          <a:p>
-            <a:pPr marL="0" indent="0" algn="ctr">
-              <a:buNone/>
-            </a:pPr>
-            <a:r>
-              <a:rPr lang="de-DE" sz="5000" dirty="0" err="1"/>
-              <a:t>Kaggle</a:t>
-            </a:r>
-            <a:r>
-              <a:rPr lang="de-DE" sz="5000" dirty="0"/>
-              <a:t>:</a:t>
-            </a:r>
-          </a:p>
-          <a:p>
-            <a:pPr marL="0" indent="0" algn="ctr">
-              <a:buNone/>
-            </a:pPr>
-            <a:r>
-              <a:rPr lang="de-DE" sz="5000" dirty="0">
-                <a:hlinkClick r:id="rId2"/>
-              </a:rPr>
-              <a:t>Natural Scene Classification</a:t>
-            </a:r>
-            <a:endParaRPr lang="de-DE" sz="5000" dirty="0"/>
-          </a:p>
-        </p:txBody>
-      </p:sp>
-    </p:spTree>
-    <p:extLst>
-      <p:ext uri="{BB962C8B-B14F-4D97-AF65-F5344CB8AC3E}">
-        <p14:creationId xmlns:p14="http://schemas.microsoft.com/office/powerpoint/2010/main" val="3312599535"/>
-      </p:ext>
-    </p:extLst>
-  </p:cSld>
-  <p:clrMapOvr>
-    <a:masterClrMapping/>
-  </p:clrMapOvr>
-</p:sld>
-</file>
-
-<file path=ppt/slides/slide9.xml><?xml version="1.0" encoding="utf-8"?>
-<p:sld xmlns:a="http://schemas.openxmlformats.org/drawingml/2006/main" xmlns:r="http://schemas.openxmlformats.org/officeDocument/2006/relationships" xmlns:p="http://schemas.openxmlformats.org/presentationml/2006/main">
-  <p:cSld>
-    <p:spTree>
-      <p:nvGrpSpPr>
-        <p:cNvPr id="1" name="">
-          <a:extLst>
-            <a:ext uri="{FF2B5EF4-FFF2-40B4-BE49-F238E27FC236}">
-              <a16:creationId xmlns:a16="http://schemas.microsoft.com/office/drawing/2014/main" id="{E1586526-30AD-DA3B-7876-1143915CF3FD}"/>
-            </a:ext>
-          </a:extLst>
-        </p:cNvPr>
-        <p:cNvGrpSpPr/>
-        <p:nvPr/>
-      </p:nvGrpSpPr>
-      <p:grpSpPr>
-        <a:xfrm>
-          <a:off x="0" y="0"/>
-          <a:ext cx="0" cy="0"/>
-          <a:chOff x="0" y="0"/>
-          <a:chExt cx="0" cy="0"/>
-        </a:xfrm>
-      </p:grpSpPr>
-      <p:sp>
-        <p:nvSpPr>
-          <p:cNvPr id="2" name="Titel 1">
-            <a:extLst>
-              <a:ext uri="{FF2B5EF4-FFF2-40B4-BE49-F238E27FC236}">
-                <a16:creationId xmlns:a16="http://schemas.microsoft.com/office/drawing/2014/main" id="{1056B9C7-BB8D-5EB8-FAB0-4352B95AF214}"/>
-              </a:ext>
-            </a:extLst>
-          </p:cNvPr>
-          <p:cNvSpPr>
-            <a:spLocks noGrp="1"/>
-          </p:cNvSpPr>
-          <p:nvPr>
-            <p:ph type="title"/>
-          </p:nvPr>
-        </p:nvSpPr>
-        <p:spPr/>
-        <p:txBody>
-          <a:bodyPr/>
-          <a:lstStyle/>
-          <a:p>
-            <a:r>
-              <a:rPr lang="de-DE" dirty="0"/>
-              <a:t>Project 3: Group 1</a:t>
-            </a:r>
-          </a:p>
-        </p:txBody>
-      </p:sp>
-      <p:sp>
-        <p:nvSpPr>
-          <p:cNvPr id="3" name="Inhaltsplatzhalter 2">
-            <a:extLst>
-              <a:ext uri="{FF2B5EF4-FFF2-40B4-BE49-F238E27FC236}">
-                <a16:creationId xmlns:a16="http://schemas.microsoft.com/office/drawing/2014/main" id="{DFA763C2-80FD-FCB2-8224-74624E0B1848}"/>
-              </a:ext>
-            </a:extLst>
-          </p:cNvPr>
-          <p:cNvSpPr>
-            <a:spLocks noGrp="1"/>
-          </p:cNvSpPr>
-          <p:nvPr>
-            <p:ph idx="1"/>
-          </p:nvPr>
-        </p:nvSpPr>
-        <p:spPr/>
-        <p:txBody>
-          <a:bodyPr>
-            <a:normAutofit/>
-          </a:bodyPr>
-          <a:lstStyle/>
-          <a:p>
-            <a:pPr marL="0" indent="0" algn="ctr">
-              <a:buNone/>
-            </a:pPr>
-            <a:endParaRPr lang="de-DE" sz="5000" dirty="0"/>
-          </a:p>
-          <a:p>
-            <a:pPr marL="0" indent="0" algn="ctr">
-              <a:buNone/>
-            </a:pPr>
-            <a:r>
-              <a:rPr lang="de-DE" sz="5000" dirty="0" err="1"/>
-              <a:t>Kaggle</a:t>
-            </a:r>
-            <a:r>
-              <a:rPr lang="de-DE" sz="5000" dirty="0"/>
-              <a:t>:</a:t>
-            </a:r>
-          </a:p>
-          <a:p>
-            <a:pPr marL="0" indent="0" algn="ctr">
-              <a:buNone/>
-            </a:pPr>
-            <a:r>
-              <a:rPr lang="de-DE" sz="5000" dirty="0">
-                <a:hlinkClick r:id="rId2"/>
-              </a:rPr>
-              <a:t>Medical Image Segmentation</a:t>
-            </a:r>
-            <a:endParaRPr lang="de-DE" sz="5000" dirty="0"/>
-          </a:p>
-        </p:txBody>
-      </p:sp>
-    </p:spTree>
-    <p:extLst>
-      <p:ext uri="{BB962C8B-B14F-4D97-AF65-F5344CB8AC3E}">
-        <p14:creationId xmlns:p14="http://schemas.microsoft.com/office/powerpoint/2010/main" val="311497940"/>
       </p:ext>
     </p:extLst>
   </p:cSld>

</xml_diff>